<commit_message>
Fill in course name and full team roster on report/deck title pages
Course: Generative AI. Team: Nonthapat T., Jeeraporn Y., Chaiphan N., Jirun T. Submission date still a placeholder.

Co-Authored-By: Claude Sonnet 5 <noreply@anthropic.com>
</commit_message>
<xml_diff>
--- a/report/Final_Presentation.pptx
+++ b/report/Final_Presentation.pptx
@@ -2063,7 +2063,7 @@
         <p:spPr>
           <a:xfrm>
             <a:off x="822960" y="5394960"/>
-            <a:ext cx="9144000" cy="365760"/>
+            <a:ext cx="10515600" cy="365760"/>
           </a:xfrm>
           <a:prstGeom prst="rect">
             <a:avLst/>
@@ -2087,7 +2087,7 @@
                 <a:ea typeface="Calibri" pitchFamily="34" charset="-122"/>
                 <a:cs typeface="Calibri" pitchFamily="34" charset="-120"/>
               </a:rPr>
-              <a:t>Nonthapat Tangjeerawong  ·  [Teammate Name]</a:t>
+              <a:t>Nonthapat T.  ·  Jeeraporn Y.  ·  Chaiphan N.  ·  Jirun T.</a:t>
             </a:r>
             <a:endParaRPr lang="en-US" sz="1500" dirty="0"/>
           </a:p>
@@ -2126,7 +2126,7 @@
                 <a:ea typeface="Calibri" pitchFamily="34" charset="-122"/>
                 <a:cs typeface="Calibri" pitchFamily="34" charset="-120"/>
               </a:rPr>
-              <a:t>[Course Name / Number]  ·  Final Project Presentation</a:t>
+              <a:t>Generative AI  ·  Final Project Presentation</a:t>
             </a:r>
             <a:endParaRPr lang="en-US" sz="1300" dirty="0"/>
           </a:p>

</xml_diff>

<commit_message>
Update token pricing: one-time all-spot 3D unlock, revised photo reward
3D walk access is now a one-time 89-token unlock covering every spot for the session, instead of a per-spot 131-token charge. Photo-review reward now requires a minimum of 3 photos (was 5) and pays 30 tokens back per spot (was a flat 35 once). Updated app logic, README, and the report/deck to match.

Co-Authored-By: Claude Sonnet 5 <noreply@anthropic.com>
</commit_message>
<xml_diff>
--- a/report/Final_Presentation.pptx
+++ b/report/Final_Presentation.pptx
@@ -2877,7 +2877,7 @@
                           <a:ea typeface="Calibri" pitchFamily="34" charset="-122"/>
                           <a:cs typeface="Calibri" pitchFamily="34" charset="-120"/>
                         </a:rPr>
-                        <a:t>Walk a spot in 3D</a:t>
+                        <a:t>Unlock 3D walking (all spots)</a:t>
                       </a:r>
                       <a:endParaRPr lang="en-US" sz="1400" dirty="0">
                         <a:latin typeface="Calibri" charset="0"/>
@@ -2945,7 +2945,7 @@
                           <a:ea typeface="Calibri" pitchFamily="34" charset="-122"/>
                           <a:cs typeface="Calibri" pitchFamily="34" charset="-120"/>
                         </a:rPr>
-                        <a:t>131 tokens (~$0.87-1.05)</a:t>
+                        <a:t>89 tokens (~$0.60-0.71, one-time)</a:t>
                       </a:r>
                       <a:endParaRPr lang="en-US" sz="1400" dirty="0">
                         <a:latin typeface="Calibri" charset="0"/>
@@ -3015,7 +3015,7 @@
                           <a:ea typeface="Calibri" pitchFamily="34" charset="-122"/>
                           <a:cs typeface="Calibri" pitchFamily="34" charset="-120"/>
                         </a:rPr>
-                        <a:t>Share 5 photos + a review</a:t>
+                        <a:t>Share 3 photos + a review, per spot</a:t>
                       </a:r>
                       <a:endParaRPr lang="en-US" sz="1400" dirty="0">
                         <a:latin typeface="Calibri" charset="0"/>
@@ -3083,7 +3083,7 @@
                           <a:ea typeface="Calibri" pitchFamily="34" charset="-122"/>
                           <a:cs typeface="Calibri" pitchFamily="34" charset="-120"/>
                         </a:rPr>
-                        <a:t>+35 tokens back</a:t>
+                        <a:t>+30 tokens back</a:t>
                       </a:r>
                       <a:endParaRPr lang="en-US" sz="1400" dirty="0">
                         <a:latin typeface="Calibri" charset="0"/>
@@ -3457,7 +3457,7 @@
                 <a:ea typeface="Calibri" pitchFamily="34" charset="-122"/>
                 <a:cs typeface="Calibri" pitchFamily="34" charset="-120"/>
               </a:rPr>
-              <a:t>Travelers upload up to 5 of their own photos per spot -&gt; vision model extracts richer ambiance -&gt; traveler earns a real 35-token reward. Fully legitimate (user-submitted, not scraped). Needs accounts, storage, and moderation — a real backend, deliberately out of scope for now.</a:t>
+              <a:t>Travelers upload up to 3 of their own photos per spot -&gt; vision model extracts richer ambiance -&gt; traveler earns a real 30-token reward per spot. Fully legitimate (user-submitted, not scraped). Needs accounts, storage, and moderation — a real backend, deliberately out of scope for now.</a:t>
             </a:r>
             <a:endParaRPr lang="en-US" sz="1350" dirty="0"/>
           </a:p>
@@ -4683,7 +4683,7 @@
                 <a:ea typeface="Calibri" pitchFamily="34" charset="-122"/>
                 <a:cs typeface="Calibri" pitchFamily="34" charset="-120"/>
               </a:rPr>
-              <a:t>Traveler walks a spot in 3D (131 tokens)</a:t>
+              <a:t>Traveler unlocks all spots in 3D once (89 tokens)</a:t>
             </a:r>
             <a:endParaRPr lang="en-US" sz="1450" dirty="0"/>
           </a:p>
@@ -5313,7 +5313,7 @@
                 <a:ea typeface="Calibri" pitchFamily="34" charset="-122"/>
                 <a:cs typeface="Calibri" pitchFamily="34" charset="-120"/>
               </a:rPr>
-              <a:t>Share 5 photos + a review, earn 35 tokens back</a:t>
+              <a:t>Share 3 photos + a review per spot, earn 30 tokens back</a:t>
             </a:r>
             <a:endParaRPr lang="en-US" sz="1450" dirty="0"/>
           </a:p>

</xml_diff>

<commit_message>
Add a tool-calling concierge agent (Lane 3)
New chat panel on the results screen backed by a genuine tool-calling agent, not another bounded extraction call like Lanes 1-2. It can call four tools - adjust_plan, get_spot_details, unlock_and_walk, download_report - each a thin wrapper around a function the app already trusted, so the model can act but never do anything the UI couldn't already do. Loop capped at 4 tool-call rounds. Confirmed gpt-5.6-luna supports real function-calling with reasoning_effort: none before building the UI around it. Updated the architecture diagram (now three lanes), report, and deck to match, including a real caught-and-fixed bug (duplicate assistant reply) documented in Results and Analysis.

Co-Authored-By: Claude Sonnet 5 <noreply@anthropic.com>
</commit_message>
<xml_diff>
--- a/report/Final_Presentation.pptx
+++ b/report/Final_Presentation.pptx
@@ -17,9 +17,10 @@
     <p:sldId id="265" r:id="rId11"/>
     <p:sldId id="266" r:id="rId12"/>
     <p:sldId id="267" r:id="rId13"/>
+    <p:sldId id="268" r:id="rId14"/>
   </p:sldIdLst>
   <p:notesMasterIdLst>
-    <p:notesMasterId r:id="rId14"/>
+    <p:notesMasterId r:id="rId15"/>
   </p:notesMasterIdLst>
   <p:sldSz cx="12192000" cy="6858000"/>
   <p:notesSz cx="6858000" cy="12192000"/>
@@ -801,6 +802,94 @@
             <a:fld id="{F7021451-1387-4CA6-816F-3879F97B5CBC}" type="slidenum">
               <a:rPr lang="en-US"/>
               <a:t>12</a:t>
+            </a:fld>
+            <a:endParaRPr lang="en-US"/>
+          </a:p>
+        </p:txBody>
+      </p:sp>
+    </p:spTree>
+    <p:extLst>
+      <p:ext uri="{BB962C8B-B14F-4D97-AF65-F5344CB8AC3E}">
+        <p14:creationId xmlns:p14="http://schemas.microsoft.com/office/powerpoint/2010/main" val="1024086991"/>
+      </p:ext>
+    </p:extLst>
+  </p:cSld>
+  <p:clrMapOvr>
+    <a:masterClrMapping/>
+  </p:clrMapOvr>
+</p:notes>
+</file>
+
+<file path=ppt/notesSlides/notesSlide13.xml><?xml version="1.0" encoding="utf-8"?>
+<p:notes xmlns:a="http://schemas.openxmlformats.org/drawingml/2006/main" xmlns:r="http://schemas.openxmlformats.org/officeDocument/2006/relationships" xmlns:p="http://schemas.openxmlformats.org/presentationml/2006/main">
+  <p:cSld>
+    <p:spTree>
+      <p:nvGrpSpPr>
+        <p:cNvPr id="1" name=""/>
+        <p:cNvGrpSpPr/>
+        <p:nvPr/>
+      </p:nvGrpSpPr>
+      <p:grpSpPr>
+        <a:xfrm>
+          <a:off x="0" y="0"/>
+          <a:ext cx="0" cy="0"/>
+          <a:chOff x="0" y="0"/>
+          <a:chExt cx="0" cy="0"/>
+        </a:xfrm>
+      </p:grpSpPr>
+      <p:sp>
+        <p:nvSpPr>
+          <p:cNvPr id="2" name="Slide Image Placeholder 1"/>
+          <p:cNvSpPr>
+            <a:spLocks noGrp="1" noRot="1" noChangeAspect="1"/>
+          </p:cNvSpPr>
+          <p:nvPr>
+            <p:ph type="sldImg"/>
+          </p:nvPr>
+        </p:nvSpPr>
+        <p:spPr/>
+      </p:sp>
+      <p:sp>
+        <p:nvSpPr>
+          <p:cNvPr id="3" name="Notes Placeholder 2"/>
+          <p:cNvSpPr>
+            <a:spLocks noGrp="1"/>
+          </p:cNvSpPr>
+          <p:nvPr>
+            <p:ph type="body" idx="1"/>
+          </p:nvPr>
+        </p:nvSpPr>
+        <p:spPr/>
+        <p:txBody>
+          <a:bodyPr/>
+          <a:lstStyle/>
+          <a:p>
+            <a:r>
+              <a:rPr lang="en-US" dirty="0"/>
+              <a:t/>
+            </a:r>
+            <a:endParaRPr lang="en-US" dirty="0"/>
+          </a:p>
+        </p:txBody>
+      </p:sp>
+      <p:sp>
+        <p:nvSpPr>
+          <p:cNvPr id="4" name="Slide Number Placeholder 3"/>
+          <p:cNvSpPr>
+            <a:spLocks noGrp="1"/>
+          </p:cNvSpPr>
+          <p:nvPr>
+            <p:ph type="sldNum" sz="quarter" idx="10"/>
+          </p:nvPr>
+        </p:nvSpPr>
+        <p:spPr/>
+        <p:txBody>
+          <a:bodyPr/>
+          <a:lstStyle/>
+          <a:p>
+            <a:fld id="{F7021451-1387-4CA6-816F-3879F97B5CBC}" type="slidenum">
+              <a:rPr lang="en-US"/>
+              <a:t>13</a:t>
             </a:fld>
             <a:endParaRPr lang="en-US"/>
           </a:p>
@@ -2185,6 +2274,255 @@
     <p:bg>
       <p:bgPr>
         <a:solidFill>
+          <a:srgbClr val="0B4F6C"/>
+        </a:solidFill>
+      </p:bgPr>
+    </p:bg>
+    <p:spTree>
+      <p:nvGrpSpPr>
+        <p:cNvPr id="1" name=""/>
+        <p:cNvGrpSpPr/>
+        <p:nvPr/>
+      </p:nvGrpSpPr>
+      <p:grpSpPr>
+        <a:xfrm>
+          <a:off x="0" y="0"/>
+          <a:ext cx="0" cy="0"/>
+          <a:chOff x="0" y="0"/>
+          <a:chExt cx="0" cy="0"/>
+        </a:xfrm>
+      </p:grpSpPr>
+      <p:sp>
+        <p:nvSpPr>
+          <p:cNvPr id="2" name="Shape 0"/>
+          <p:cNvSpPr/>
+          <p:nvPr/>
+        </p:nvSpPr>
+        <p:spPr>
+          <a:xfrm>
+            <a:off x="-1097280" y="4480560"/>
+            <a:ext cx="2926080" cy="2926080"/>
+          </a:xfrm>
+          <a:prstGeom prst="ellipse">
+            <a:avLst/>
+          </a:prstGeom>
+          <a:solidFill>
+            <a:srgbClr val="F2724B">
+              <a:alpha val="12000"/>
+            </a:srgbClr>
+          </a:solidFill>
+          <a:ln/>
+        </p:spPr>
+      </p:sp>
+      <p:sp>
+        <p:nvSpPr>
+          <p:cNvPr id="3" name="Text 1"/>
+          <p:cNvSpPr/>
+          <p:nvPr/>
+        </p:nvSpPr>
+        <p:spPr>
+          <a:xfrm>
+            <a:off x="822960" y="1005840"/>
+            <a:ext cx="9144000" cy="640080"/>
+          </a:xfrm>
+          <a:prstGeom prst="rect">
+            <a:avLst/>
+          </a:prstGeom>
+          <a:noFill/>
+          <a:ln/>
+        </p:spPr>
+        <p:txBody>
+          <a:bodyPr wrap="square" lIns="0" tIns="0" rIns="0" bIns="0" rtlCol="0" anchor="ctr"/>
+          <a:lstStyle/>
+          <a:p>
+            <a:pPr indent="0" marL="0">
+              <a:buNone/>
+            </a:pPr>
+            <a:r>
+              <a:rPr lang="en-US" sz="3000" b="1" dirty="0">
+                <a:solidFill>
+                  <a:srgbClr val="FFFFFF"/>
+                </a:solidFill>
+                <a:latin typeface="Cambria" pitchFamily="34" charset="0"/>
+                <a:ea typeface="Cambria" pitchFamily="34" charset="-122"/>
+                <a:cs typeface="Cambria" pitchFamily="34" charset="-120"/>
+              </a:rPr>
+              <a:t>One Honest Limitation</a:t>
+            </a:r>
+            <a:endParaRPr lang="en-US" sz="3000" dirty="0"/>
+          </a:p>
+        </p:txBody>
+      </p:sp>
+      <p:sp>
+        <p:nvSpPr>
+          <p:cNvPr id="4" name="Text 2"/>
+          <p:cNvSpPr/>
+          <p:nvPr/>
+        </p:nvSpPr>
+        <p:spPr>
+          <a:xfrm>
+            <a:off x="822960" y="1920240"/>
+            <a:ext cx="10058400" cy="914400"/>
+          </a:xfrm>
+          <a:prstGeom prst="rect">
+            <a:avLst/>
+          </a:prstGeom>
+          <a:noFill/>
+          <a:ln/>
+        </p:spPr>
+        <p:txBody>
+          <a:bodyPr wrap="square" lIns="0" tIns="0" rIns="0" bIns="0" rtlCol="0" anchor="ctr"/>
+          <a:lstStyle/>
+          <a:p>
+            <a:pPr indent="0" marL="0">
+              <a:buNone/>
+            </a:pPr>
+            <a:r>
+              <a:rPr lang="en-US" sz="2000" dirty="0">
+                <a:solidFill>
+                  <a:srgbClr val="FFCF5C"/>
+                </a:solidFill>
+                <a:latin typeface="Calibri" pitchFamily="34" charset="0"/>
+                <a:ea typeface="Calibri" pitchFamily="34" charset="-122"/>
+                <a:cs typeface="Calibri" pitchFamily="34" charset="-120"/>
+              </a:rPr>
+              <a:t>The 3D scenes are stylized, low-poly interpretations — not photorealistic reconstructions of the real locations.</a:t>
+            </a:r>
+            <a:endParaRPr lang="en-US" sz="2000" dirty="0"/>
+          </a:p>
+        </p:txBody>
+      </p:sp>
+      <p:sp>
+        <p:nvSpPr>
+          <p:cNvPr id="5" name="Text 3"/>
+          <p:cNvSpPr/>
+          <p:nvPr/>
+        </p:nvSpPr>
+        <p:spPr>
+          <a:xfrm>
+            <a:off x="822960" y="3017520"/>
+            <a:ext cx="9509760" cy="1463040"/>
+          </a:xfrm>
+          <a:prstGeom prst="rect">
+            <a:avLst/>
+          </a:prstGeom>
+          <a:noFill/>
+          <a:ln/>
+        </p:spPr>
+        <p:txBody>
+          <a:bodyPr wrap="square" lIns="0" tIns="0" rIns="0" bIns="0" rtlCol="0" anchor="ctr"/>
+          <a:lstStyle/>
+          <a:p>
+            <a:pPr indent="0" marL="0">
+              <a:buNone/>
+            </a:pPr>
+            <a:r>
+              <a:rPr lang="en-US" sz="1500" dirty="0">
+                <a:solidFill>
+                  <a:srgbClr val="CFE3E8"/>
+                </a:solidFill>
+                <a:latin typeface="Calibri" pitchFamily="34" charset="0"/>
+                <a:ea typeface="Calibri" pitchFamily="34" charset="-122"/>
+                <a:cs typeface="Calibri" pitchFamily="34" charset="-120"/>
+              </a:rPr>
+              <a:t>True 3D reconstruction needs dozens of calibrated, overlapping photos (photogrammetry / NeRF) — not review text or a handful of casual photos. We chose to be upfront about this rather than overclaim, and built a deterministic, review-grounded stylized scene instead. The token economy is the same story: presented in full, built as local state only — no real payment happens anywhere in this demo.</a:t>
+            </a:r>
+            <a:endParaRPr lang="en-US" sz="1500" dirty="0"/>
+          </a:p>
+        </p:txBody>
+      </p:sp>
+      <p:sp>
+        <p:nvSpPr>
+          <p:cNvPr id="6" name="Text 4"/>
+          <p:cNvSpPr/>
+          <p:nvPr/>
+        </p:nvSpPr>
+        <p:spPr>
+          <a:xfrm>
+            <a:off x="822960" y="4754880"/>
+            <a:ext cx="9509760" cy="914400"/>
+          </a:xfrm>
+          <a:prstGeom prst="rect">
+            <a:avLst/>
+          </a:prstGeom>
+          <a:noFill/>
+          <a:ln/>
+        </p:spPr>
+        <p:txBody>
+          <a:bodyPr wrap="square" lIns="0" tIns="0" rIns="0" bIns="0" rtlCol="0" anchor="ctr"/>
+          <a:lstStyle/>
+          <a:p>
+            <a:pPr indent="0" marL="0">
+              <a:buNone/>
+            </a:pPr>
+            <a:r>
+              <a:rPr lang="en-US" sz="1350" i="1" dirty="0">
+                <a:solidFill>
+                  <a:srgbClr val="9FB8B0"/>
+                </a:solidFill>
+                <a:latin typeface="Calibri" pitchFamily="34" charset="0"/>
+                <a:ea typeface="Calibri" pitchFamily="34" charset="-122"/>
+                <a:cs typeface="Calibri" pitchFamily="34" charset="-120"/>
+              </a:rPr>
+              <a:t>Also flagged: WASD movement needs a final real-browser verification pass (automated headless testing was inconclusive due to background-tab throttling).</a:t>
+            </a:r>
+            <a:endParaRPr lang="en-US" sz="1350" dirty="0"/>
+          </a:p>
+        </p:txBody>
+      </p:sp>
+      <p:sp>
+        <p:nvSpPr>
+          <p:cNvPr id="7" name="Text 5"/>
+          <p:cNvSpPr/>
+          <p:nvPr/>
+        </p:nvSpPr>
+        <p:spPr>
+          <a:xfrm>
+            <a:off x="457200" y="6510528"/>
+            <a:ext cx="5486400" cy="274320"/>
+          </a:xfrm>
+          <a:prstGeom prst="rect">
+            <a:avLst/>
+          </a:prstGeom>
+          <a:noFill/>
+          <a:ln/>
+        </p:spPr>
+        <p:txBody>
+          <a:bodyPr wrap="square" lIns="0" tIns="0" rIns="0" bIns="0" rtlCol="0" anchor="ctr"/>
+          <a:lstStyle/>
+          <a:p>
+            <a:pPr indent="0" marL="0">
+              <a:buNone/>
+            </a:pPr>
+            <a:r>
+              <a:rPr lang="en-US" sz="1000" dirty="0">
+                <a:solidFill>
+                  <a:srgbClr val="CFE3E8"/>
+                </a:solidFill>
+                <a:latin typeface="Calibri" pitchFamily="34" charset="0"/>
+                <a:ea typeface="Calibri" pitchFamily="34" charset="-122"/>
+                <a:cs typeface="Calibri" pitchFamily="34" charset="-120"/>
+              </a:rPr>
+              <a:t>https://github.com/GongNT/travel-3d-simulator</a:t>
+            </a:r>
+            <a:endParaRPr lang="en-US" sz="1000" dirty="0"/>
+          </a:p>
+        </p:txBody>
+      </p:sp>
+    </p:spTree>
+  </p:cSld>
+  <p:clrMapOvr>
+    <a:masterClrMapping/>
+  </p:clrMapOvr>
+</p:sld>
+</file>
+
+<file path=ppt/slides/slide11.xml><?xml version="1.0" encoding="utf-8"?>
+<p:sld xmlns:a="http://schemas.openxmlformats.org/drawingml/2006/main" xmlns:r="http://schemas.openxmlformats.org/officeDocument/2006/relationships" xmlns:p="http://schemas.openxmlformats.org/presentationml/2006/main">
+  <p:cSld name="Slide 11">
+    <p:bg>
+      <p:bgPr>
+        <a:solidFill>
           <a:srgbClr val="FFFFFF"/>
         </a:solidFill>
       </p:bgPr>
@@ -2283,7 +2621,7 @@
       </p:sp>
       <p:graphicFrame>
         <p:nvGraphicFramePr>
-          <p:cNvPr id="11" name="Table 0"/>
+          <p:cNvPr id="12" name="Table 0"/>
           <p:cNvGraphicFramePr>
             <a:graphicFrameLocks noGrp="1"/>
           </p:cNvGraphicFramePr>
@@ -3293,9 +3631,9 @@
 </p:sld>
 </file>
 
-<file path=ppt/slides/slide11.xml><?xml version="1.0" encoding="utf-8"?>
+<file path=ppt/slides/slide12.xml><?xml version="1.0" encoding="utf-8"?>
 <p:sld xmlns:a="http://schemas.openxmlformats.org/drawingml/2006/main" xmlns:r="http://schemas.openxmlformats.org/officeDocument/2006/relationships" xmlns:p="http://schemas.openxmlformats.org/presentationml/2006/main">
-  <p:cSld name="Slide 11">
+  <p:cSld name="Slide 12">
     <p:bg>
       <p:bgPr>
         <a:solidFill>
@@ -3658,9 +3996,9 @@
 </p:sld>
 </file>
 
-<file path=ppt/slides/slide12.xml><?xml version="1.0" encoding="utf-8"?>
+<file path=ppt/slides/slide13.xml><?xml version="1.0" encoding="utf-8"?>
 <p:sld xmlns:a="http://schemas.openxmlformats.org/drawingml/2006/main" xmlns:r="http://schemas.openxmlformats.org/officeDocument/2006/relationships" xmlns:p="http://schemas.openxmlformats.org/presentationml/2006/main">
-  <p:cSld name="Slide 12">
+  <p:cSld name="Slide 13">
     <p:bg>
       <p:bgPr>
         <a:solidFill>
@@ -5501,7 +5839,7 @@
                 <a:ea typeface="Calibri" pitchFamily="34" charset="-122"/>
                 <a:cs typeface="Calibri" pitchFamily="34" charset="-120"/>
               </a:rPr>
-              <a:t>Two narrow LLM extraction steps; the decisions themselves — including the live editor — are ordinary deterministic code.</a:t>
+              <a:t>Three lanes of narrow LLM steps; every decision and every agent tool call bottoms out in ordinary deterministic code.</a:t>
             </a:r>
             <a:endParaRPr lang="en-US" sz="1400" dirty="0"/>
           </a:p>
@@ -5523,8 +5861,8 @@
         </p:blipFill>
         <p:spPr>
           <a:xfrm>
-            <a:off x="548640" y="1371600"/>
-            <a:ext cx="11064240" cy="2516288"/>
+            <a:off x="1705356" y="1417320"/>
+            <a:ext cx="8778240" cy="5131894"/>
           </a:xfrm>
           <a:prstGeom prst="rect">
             <a:avLst/>
@@ -5581,6 +5919,348 @@
 <file path=ppt/slides/slide7.xml><?xml version="1.0" encoding="utf-8"?>
 <p:sld xmlns:a="http://schemas.openxmlformats.org/drawingml/2006/main" xmlns:r="http://schemas.openxmlformats.org/officeDocument/2006/relationships" xmlns:p="http://schemas.openxmlformats.org/presentationml/2006/main">
   <p:cSld name="Slide 7">
+    <p:bg>
+      <p:bgPr>
+        <a:solidFill>
+          <a:srgbClr val="0B4F6C"/>
+        </a:solidFill>
+      </p:bgPr>
+    </p:bg>
+    <p:spTree>
+      <p:nvGrpSpPr>
+        <p:cNvPr id="1" name=""/>
+        <p:cNvGrpSpPr/>
+        <p:nvPr/>
+      </p:nvGrpSpPr>
+      <p:grpSpPr>
+        <a:xfrm>
+          <a:off x="0" y="0"/>
+          <a:ext cx="0" cy="0"/>
+          <a:chOff x="0" y="0"/>
+          <a:chExt cx="0" cy="0"/>
+        </a:xfrm>
+      </p:grpSpPr>
+      <p:sp>
+        <p:nvSpPr>
+          <p:cNvPr id="2" name="Text 0"/>
+          <p:cNvSpPr/>
+          <p:nvPr/>
+        </p:nvSpPr>
+        <p:spPr>
+          <a:xfrm>
+            <a:off x="548640" y="365760"/>
+            <a:ext cx="9144000" cy="548640"/>
+          </a:xfrm>
+          <a:prstGeom prst="rect">
+            <a:avLst/>
+          </a:prstGeom>
+          <a:noFill/>
+          <a:ln/>
+        </p:spPr>
+        <p:txBody>
+          <a:bodyPr wrap="square" lIns="0" tIns="0" rIns="0" bIns="0" rtlCol="0" anchor="ctr"/>
+          <a:lstStyle/>
+          <a:p>
+            <a:pPr indent="0" marL="0">
+              <a:buNone/>
+            </a:pPr>
+            <a:r>
+              <a:rPr lang="en-US" sz="2500" b="1" dirty="0">
+                <a:solidFill>
+                  <a:srgbClr val="FFFFFF"/>
+                </a:solidFill>
+                <a:latin typeface="Cambria" pitchFamily="34" charset="0"/>
+                <a:ea typeface="Cambria" pitchFamily="34" charset="-122"/>
+                <a:cs typeface="Cambria" pitchFamily="34" charset="-120"/>
+              </a:rPr>
+              <a:t>Demo — Ask the Concierge (Lane 3)</a:t>
+            </a:r>
+            <a:endParaRPr lang="en-US" sz="2500" dirty="0"/>
+          </a:p>
+        </p:txBody>
+      </p:sp>
+      <p:sp>
+        <p:nvSpPr>
+          <p:cNvPr id="3" name="Text 1"/>
+          <p:cNvSpPr/>
+          <p:nvPr/>
+        </p:nvSpPr>
+        <p:spPr>
+          <a:xfrm>
+            <a:off x="548640" y="868680"/>
+            <a:ext cx="10972800" cy="365760"/>
+          </a:xfrm>
+          <a:prstGeom prst="rect">
+            <a:avLst/>
+          </a:prstGeom>
+          <a:noFill/>
+          <a:ln/>
+        </p:spPr>
+        <p:txBody>
+          <a:bodyPr wrap="square" lIns="0" tIns="0" rIns="0" bIns="0" rtlCol="0" anchor="ctr"/>
+          <a:lstStyle/>
+          <a:p>
+            <a:pPr indent="0" marL="0">
+              <a:buNone/>
+            </a:pPr>
+            <a:r>
+              <a:rPr lang="en-US" sz="1350" i="1" dirty="0">
+                <a:solidFill>
+                  <a:srgbClr val="CFE3E8"/>
+                </a:solidFill>
+                <a:latin typeface="Calibri" pitchFamily="34" charset="0"/>
+                <a:ea typeface="Calibri" pitchFamily="34" charset="-122"/>
+                <a:cs typeface="Calibri" pitchFamily="34" charset="-120"/>
+              </a:rPr>
+              <a:t>A real tool-calling agent - four tools, each a thin wrapper around a function the app already trusted.</a:t>
+            </a:r>
+            <a:endParaRPr lang="en-US" sz="1350" dirty="0"/>
+          </a:p>
+        </p:txBody>
+      </p:sp>
+      <p:pic>
+        <p:nvPicPr>
+          <p:cNvPr id="4" name="Image 0" descr="/Users/gong/Desktop/Sasin/Gen AI Class/travel-3d-simulator/report/figures/concierge_chat.png">    </p:cNvPr>
+          <p:cNvPicPr>
+            <a:picLocks noChangeAspect="1"/>
+          </p:cNvPicPr>
+          <p:nvPr/>
+        </p:nvPicPr>
+        <p:blipFill>
+          <a:blip r:embed="rId1"/>
+          <a:stretch>
+            <a:fillRect/>
+          </a:stretch>
+        </p:blipFill>
+        <p:spPr>
+          <a:xfrm>
+            <a:off x="4206240" y="2011680"/>
+            <a:ext cx="7315200" cy="2165684"/>
+          </a:xfrm>
+          <a:prstGeom prst="rect">
+            <a:avLst/>
+          </a:prstGeom>
+        </p:spPr>
+      </p:pic>
+      <p:sp>
+        <p:nvSpPr>
+          <p:cNvPr id="5" name="Shape 2"/>
+          <p:cNvSpPr/>
+          <p:nvPr/>
+        </p:nvSpPr>
+        <p:spPr>
+          <a:xfrm>
+            <a:off x="4206240" y="2011680"/>
+            <a:ext cx="7315200" cy="2165684"/>
+          </a:xfrm>
+          <a:prstGeom prst="roundRect">
+            <a:avLst>
+              <a:gd name="adj" fmla="val 1689"/>
+            </a:avLst>
+          </a:prstGeom>
+          <a:ln w="19050">
+            <a:solidFill>
+              <a:srgbClr val="F4A300"/>
+            </a:solidFill>
+            <a:prstDash val="solid"/>
+          </a:ln>
+        </p:spPr>
+      </p:sp>
+      <p:sp>
+        <p:nvSpPr>
+          <p:cNvPr id="6" name="Text 3"/>
+          <p:cNvSpPr/>
+          <p:nvPr/>
+        </p:nvSpPr>
+        <p:spPr>
+          <a:xfrm>
+            <a:off x="548640" y="1463040"/>
+            <a:ext cx="3383280" cy="4114800"/>
+          </a:xfrm>
+          <a:prstGeom prst="rect">
+            <a:avLst/>
+          </a:prstGeom>
+          <a:noFill/>
+          <a:ln/>
+        </p:spPr>
+        <p:txBody>
+          <a:bodyPr wrap="square" lIns="0" tIns="0" rIns="0" bIns="0" rtlCol="0" anchor="ctr"/>
+          <a:lstStyle/>
+          <a:p>
+            <a:pPr marL="342900" indent="-342900">
+              <a:spcAft>
+                <a:spcPts val="1600"/>
+              </a:spcAft>
+              <a:buSzPct val="100000"/>
+              <a:buChar char="•"/>
+            </a:pPr>
+            <a:r>
+              <a:rPr lang="en-US" sz="1450" dirty="0">
+                <a:solidFill>
+                  <a:srgbClr val="FFFFFF"/>
+                </a:solidFill>
+                <a:latin typeface="Calibri" pitchFamily="34" charset="0"/>
+                <a:ea typeface="Calibri" pitchFamily="34" charset="-122"/>
+                <a:cs typeface="Calibri" pitchFamily="34" charset="-120"/>
+              </a:rPr>
+              <a:t>adjust_plan - "make it cheaper" re-ranks live</a:t>
+            </a:r>
+            <a:endParaRPr lang="en-US" sz="1450" dirty="0"/>
+          </a:p>
+          <a:p>
+            <a:pPr marL="342900" indent="-342900">
+              <a:spcAft>
+                <a:spcPts val="1600"/>
+              </a:spcAft>
+              <a:buSzPct val="100000"/>
+              <a:buChar char="•"/>
+            </a:pPr>
+            <a:r>
+              <a:rPr lang="en-US" sz="1450" dirty="0">
+                <a:solidFill>
+                  <a:srgbClr val="FFFFFF"/>
+                </a:solidFill>
+                <a:latin typeface="Calibri" pitchFamily="34" charset="0"/>
+                <a:ea typeface="Calibri" pitchFamily="34" charset="-122"/>
+                <a:cs typeface="Calibri" pitchFamily="34" charset="-120"/>
+              </a:rPr>
+              <a:t>get_spot_details - answers grounded in curated reviews</a:t>
+            </a:r>
+            <a:endParaRPr lang="en-US" sz="1450" dirty="0"/>
+          </a:p>
+          <a:p>
+            <a:pPr marL="342900" indent="-342900">
+              <a:spcAft>
+                <a:spcPts val="1600"/>
+              </a:spcAft>
+              <a:buSzPct val="100000"/>
+              <a:buChar char="•"/>
+            </a:pPr>
+            <a:r>
+              <a:rPr lang="en-US" sz="1450" dirty="0">
+                <a:solidFill>
+                  <a:srgbClr val="FFFFFF"/>
+                </a:solidFill>
+                <a:latin typeface="Calibri" pitchFamily="34" charset="0"/>
+                <a:ea typeface="Calibri" pitchFamily="34" charset="-122"/>
+                <a:cs typeface="Calibri" pitchFamily="34" charset="-120"/>
+              </a:rPr>
+              <a:t>unlock_and_walk - "walk me around the market" opens the 3D scene</a:t>
+            </a:r>
+            <a:endParaRPr lang="en-US" sz="1450" dirty="0"/>
+          </a:p>
+          <a:p>
+            <a:pPr marL="342900" indent="-342900">
+              <a:spcAft>
+                <a:spcPts val="1600"/>
+              </a:spcAft>
+              <a:buSzPct val="100000"/>
+              <a:buChar char="•"/>
+            </a:pPr>
+            <a:r>
+              <a:rPr lang="en-US" sz="1450" dirty="0">
+                <a:solidFill>
+                  <a:srgbClr val="FFFFFF"/>
+                </a:solidFill>
+                <a:latin typeface="Calibri" pitchFamily="34" charset="0"/>
+                <a:ea typeface="Calibri" pitchFamily="34" charset="-122"/>
+                <a:cs typeface="Calibri" pitchFamily="34" charset="-120"/>
+              </a:rPr>
+              <a:t>download_report - saves the plan report</a:t>
+            </a:r>
+            <a:endParaRPr lang="en-US" sz="1450" dirty="0"/>
+          </a:p>
+        </p:txBody>
+      </p:sp>
+      <p:sp>
+        <p:nvSpPr>
+          <p:cNvPr id="7" name="Text 4"/>
+          <p:cNvSpPr/>
+          <p:nvPr/>
+        </p:nvSpPr>
+        <p:spPr>
+          <a:xfrm>
+            <a:off x="548640" y="5760720"/>
+            <a:ext cx="3657600" cy="548640"/>
+          </a:xfrm>
+          <a:prstGeom prst="rect">
+            <a:avLst/>
+          </a:prstGeom>
+          <a:noFill/>
+          <a:ln/>
+        </p:spPr>
+        <p:txBody>
+          <a:bodyPr wrap="square" lIns="0" tIns="0" rIns="0" bIns="0" rtlCol="0" anchor="ctr"/>
+          <a:lstStyle/>
+          <a:p>
+            <a:pPr indent="0" marL="0">
+              <a:buNone/>
+            </a:pPr>
+            <a:r>
+              <a:rPr lang="en-US" sz="1200" i="1" dirty="0">
+                <a:solidFill>
+                  <a:srgbClr val="9FB8B0"/>
+                </a:solidFill>
+                <a:latin typeface="Calibri" pitchFamily="34" charset="0"/>
+                <a:ea typeface="Calibri" pitchFamily="34" charset="-122"/>
+                <a:cs typeface="Calibri" pitchFamily="34" charset="-120"/>
+              </a:rPr>
+              <a:t>Capped at 4 tool-call rounds per turn - no runaway loops.</a:t>
+            </a:r>
+            <a:endParaRPr lang="en-US" sz="1200" dirty="0"/>
+          </a:p>
+        </p:txBody>
+      </p:sp>
+      <p:sp>
+        <p:nvSpPr>
+          <p:cNvPr id="8" name="Text 5"/>
+          <p:cNvSpPr/>
+          <p:nvPr/>
+        </p:nvSpPr>
+        <p:spPr>
+          <a:xfrm>
+            <a:off x="457200" y="6510528"/>
+            <a:ext cx="5486400" cy="274320"/>
+          </a:xfrm>
+          <a:prstGeom prst="rect">
+            <a:avLst/>
+          </a:prstGeom>
+          <a:noFill/>
+          <a:ln/>
+        </p:spPr>
+        <p:txBody>
+          <a:bodyPr wrap="square" lIns="0" tIns="0" rIns="0" bIns="0" rtlCol="0" anchor="ctr"/>
+          <a:lstStyle/>
+          <a:p>
+            <a:pPr indent="0" marL="0">
+              <a:buNone/>
+            </a:pPr>
+            <a:r>
+              <a:rPr lang="en-US" sz="1000" dirty="0">
+                <a:solidFill>
+                  <a:srgbClr val="CFE3E8"/>
+                </a:solidFill>
+                <a:latin typeface="Calibri" pitchFamily="34" charset="0"/>
+                <a:ea typeface="Calibri" pitchFamily="34" charset="-122"/>
+                <a:cs typeface="Calibri" pitchFamily="34" charset="-120"/>
+              </a:rPr>
+              <a:t>https://github.com/GongNT/travel-3d-simulator</a:t>
+            </a:r>
+            <a:endParaRPr lang="en-US" sz="1000" dirty="0"/>
+          </a:p>
+        </p:txBody>
+      </p:sp>
+    </p:spTree>
+  </p:cSld>
+  <p:clrMapOvr>
+    <a:masterClrMapping/>
+  </p:clrMapOvr>
+</p:sld>
+</file>
+
+<file path=ppt/slides/slide8.xml><?xml version="1.0" encoding="utf-8"?>
+<p:sld xmlns:a="http://schemas.openxmlformats.org/drawingml/2006/main" xmlns:r="http://schemas.openxmlformats.org/officeDocument/2006/relationships" xmlns:p="http://schemas.openxmlformats.org/presentationml/2006/main">
+  <p:cSld name="Slide 8">
     <p:bg>
       <p:bgPr>
         <a:solidFill>
@@ -5650,7 +6330,7 @@
         <p:spPr>
           <a:xfrm>
             <a:off x="822960" y="1234440"/>
-            <a:ext cx="9601200" cy="548640"/>
+            <a:ext cx="10058400" cy="548640"/>
           </a:xfrm>
           <a:prstGeom prst="rect">
             <a:avLst/>
@@ -5666,7 +6346,7 @@
               <a:buNone/>
             </a:pPr>
             <a:r>
-              <a:rPr lang="en-US" sz="1700" i="1" dirty="0">
+              <a:rPr lang="en-US" sz="1550" i="1" dirty="0">
                 <a:solidFill>
                   <a:srgbClr val="4A5D55"/>
                 </a:solidFill>
@@ -5674,9 +6354,9 @@
                 <a:ea typeface="Calibri" pitchFamily="34" charset="-122"/>
                 <a:cs typeface="Calibri" pitchFamily="34" charset="-120"/>
               </a:rPr>
-              <a:t>The LLM translates. It never decides.</a:t>
-            </a:r>
-            <a:endParaRPr lang="en-US" sz="1700" dirty="0"/>
+              <a:t>Lanes 1-2: the LLM translates, it never decides. Lane 3 may act - but only through tools that wrap trusted code.</a:t>
+            </a:r>
+            <a:endParaRPr lang="en-US" sz="1550" dirty="0"/>
           </a:p>
         </p:txBody>
       </p:sp>
@@ -6056,299 +6736,6 @@
               <a:rPr lang="en-US" sz="1000" dirty="0">
                 <a:solidFill>
                   <a:srgbClr val="8A9A93"/>
-                </a:solidFill>
-                <a:latin typeface="Calibri" pitchFamily="34" charset="0"/>
-                <a:ea typeface="Calibri" pitchFamily="34" charset="-122"/>
-                <a:cs typeface="Calibri" pitchFamily="34" charset="-120"/>
-              </a:rPr>
-              <a:t>https://github.com/GongNT/travel-3d-simulator</a:t>
-            </a:r>
-            <a:endParaRPr lang="en-US" sz="1000" dirty="0"/>
-          </a:p>
-        </p:txBody>
-      </p:sp>
-    </p:spTree>
-  </p:cSld>
-  <p:clrMapOvr>
-    <a:masterClrMapping/>
-  </p:clrMapOvr>
-</p:sld>
-</file>
-
-<file path=ppt/slides/slide8.xml><?xml version="1.0" encoding="utf-8"?>
-<p:sld xmlns:a="http://schemas.openxmlformats.org/drawingml/2006/main" xmlns:r="http://schemas.openxmlformats.org/officeDocument/2006/relationships" xmlns:p="http://schemas.openxmlformats.org/presentationml/2006/main">
-  <p:cSld name="Slide 8">
-    <p:bg>
-      <p:bgPr>
-        <a:solidFill>
-          <a:srgbClr val="0B4F6C"/>
-        </a:solidFill>
-      </p:bgPr>
-    </p:bg>
-    <p:spTree>
-      <p:nvGrpSpPr>
-        <p:cNvPr id="1" name=""/>
-        <p:cNvGrpSpPr/>
-        <p:nvPr/>
-      </p:nvGrpSpPr>
-      <p:grpSpPr>
-        <a:xfrm>
-          <a:off x="0" y="0"/>
-          <a:ext cx="0" cy="0"/>
-          <a:chOff x="0" y="0"/>
-          <a:chExt cx="0" cy="0"/>
-        </a:xfrm>
-      </p:grpSpPr>
-      <p:sp>
-        <p:nvSpPr>
-          <p:cNvPr id="2" name="Text 0"/>
-          <p:cNvSpPr/>
-          <p:nvPr/>
-        </p:nvSpPr>
-        <p:spPr>
-          <a:xfrm>
-            <a:off x="822960" y="640080"/>
-            <a:ext cx="9601200" cy="640080"/>
-          </a:xfrm>
-          <a:prstGeom prst="rect">
-            <a:avLst/>
-          </a:prstGeom>
-          <a:noFill/>
-          <a:ln/>
-        </p:spPr>
-        <p:txBody>
-          <a:bodyPr wrap="square" lIns="0" tIns="0" rIns="0" bIns="0" rtlCol="0" anchor="ctr"/>
-          <a:lstStyle/>
-          <a:p>
-            <a:pPr indent="0" marL="0">
-              <a:buNone/>
-            </a:pPr>
-            <a:r>
-              <a:rPr lang="en-US" sz="2800" b="1" dirty="0">
-                <a:solidFill>
-                  <a:srgbClr val="FFFFFF"/>
-                </a:solidFill>
-                <a:latin typeface="Cambria" pitchFamily="34" charset="0"/>
-                <a:ea typeface="Cambria" pitchFamily="34" charset="-122"/>
-                <a:cs typeface="Cambria" pitchFamily="34" charset="-120"/>
-              </a:rPr>
-              <a:t>A Real Integration Bug We Hit</a:t>
-            </a:r>
-            <a:endParaRPr lang="en-US" sz="2800" dirty="0"/>
-          </a:p>
-        </p:txBody>
-      </p:sp>
-      <p:sp>
-        <p:nvSpPr>
-          <p:cNvPr id="3" name="Text 1"/>
-          <p:cNvSpPr/>
-          <p:nvPr/>
-        </p:nvSpPr>
-        <p:spPr>
-          <a:xfrm>
-            <a:off x="822960" y="1463040"/>
-            <a:ext cx="10241280" cy="640080"/>
-          </a:xfrm>
-          <a:prstGeom prst="rect">
-            <a:avLst/>
-          </a:prstGeom>
-          <a:noFill/>
-          <a:ln/>
-        </p:spPr>
-        <p:txBody>
-          <a:bodyPr wrap="square" lIns="0" tIns="0" rIns="0" bIns="0" rtlCol="0" anchor="ctr"/>
-          <a:lstStyle/>
-          <a:p>
-            <a:pPr indent="0" marL="0">
-              <a:buNone/>
-            </a:pPr>
-            <a:r>
-              <a:rPr lang="en-US" sz="1600" dirty="0">
-                <a:solidFill>
-                  <a:srgbClr val="CFE3E8"/>
-                </a:solidFill>
-                <a:latin typeface="Calibri" pitchFamily="34" charset="0"/>
-                <a:ea typeface="Calibri" pitchFamily="34" charset="-122"/>
-                <a:cs typeface="Calibri" pitchFamily="34" charset="-120"/>
-              </a:rPr>
-              <a:t>gpt-5.6-luna rejects function-tool calling combined with its default reasoning_effort on /v1/chat/completions.</a:t>
-            </a:r>
-            <a:endParaRPr lang="en-US" sz="1600" dirty="0"/>
-          </a:p>
-        </p:txBody>
-      </p:sp>
-      <p:sp>
-        <p:nvSpPr>
-          <p:cNvPr id="4" name="Shape 2"/>
-          <p:cNvSpPr/>
-          <p:nvPr/>
-        </p:nvSpPr>
-        <p:spPr>
-          <a:xfrm>
-            <a:off x="822960" y="2377440"/>
-            <a:ext cx="10241280" cy="1828800"/>
-          </a:xfrm>
-          <a:prstGeom prst="roundRect">
-            <a:avLst>
-              <a:gd name="adj" fmla="val 5000"/>
-            </a:avLst>
-          </a:prstGeom>
-          <a:solidFill>
-            <a:srgbClr val="062B3D"/>
-          </a:solidFill>
-          <a:ln w="12700">
-            <a:solidFill>
-              <a:srgbClr val="0C8599"/>
-            </a:solidFill>
-            <a:prstDash val="solid"/>
-          </a:ln>
-        </p:spPr>
-      </p:sp>
-      <p:sp>
-        <p:nvSpPr>
-          <p:cNvPr id="5" name="Text 3"/>
-          <p:cNvSpPr/>
-          <p:nvPr/>
-        </p:nvSpPr>
-        <p:spPr>
-          <a:xfrm>
-            <a:off x="1097280" y="2606040"/>
-            <a:ext cx="9692640" cy="457200"/>
-          </a:xfrm>
-          <a:prstGeom prst="rect">
-            <a:avLst/>
-          </a:prstGeom>
-          <a:noFill/>
-          <a:ln/>
-        </p:spPr>
-        <p:txBody>
-          <a:bodyPr wrap="square" lIns="0" tIns="0" rIns="0" bIns="0" rtlCol="0" anchor="ctr"/>
-          <a:lstStyle/>
-          <a:p>
-            <a:pPr indent="0" marL="0">
-              <a:buNone/>
-            </a:pPr>
-            <a:r>
-              <a:rPr lang="en-US" sz="1500" dirty="0">
-                <a:solidFill>
-                  <a:srgbClr val="F2724B"/>
-                </a:solidFill>
-                <a:latin typeface="Courier New" pitchFamily="34" charset="0"/>
-                <a:ea typeface="Courier New" pitchFamily="34" charset="-122"/>
-                <a:cs typeface="Courier New" pitchFamily="34" charset="-120"/>
-              </a:rPr>
-              <a:t>invalid_request_error — param: reasoning_effort</a:t>
-            </a:r>
-            <a:endParaRPr lang="en-US" sz="1500" dirty="0"/>
-          </a:p>
-        </p:txBody>
-      </p:sp>
-      <p:sp>
-        <p:nvSpPr>
-          <p:cNvPr id="6" name="Text 4"/>
-          <p:cNvSpPr/>
-          <p:nvPr/>
-        </p:nvSpPr>
-        <p:spPr>
-          <a:xfrm>
-            <a:off x="1097280" y="3063240"/>
-            <a:ext cx="9692640" cy="1005840"/>
-          </a:xfrm>
-          <a:prstGeom prst="rect">
-            <a:avLst/>
-          </a:prstGeom>
-          <a:noFill/>
-          <a:ln/>
-        </p:spPr>
-        <p:txBody>
-          <a:bodyPr wrap="square" lIns="0" tIns="0" rIns="0" bIns="0" rtlCol="0" anchor="ctr"/>
-          <a:lstStyle/>
-          <a:p>
-            <a:pPr indent="0" marL="0">
-              <a:buNone/>
-            </a:pPr>
-            <a:r>
-              <a:rPr lang="en-US" sz="1300" dirty="0">
-                <a:solidFill>
-                  <a:srgbClr val="CFE3E8"/>
-                </a:solidFill>
-                <a:latin typeface="Courier New" pitchFamily="34" charset="0"/>
-                <a:ea typeface="Courier New" pitchFamily="34" charset="-122"/>
-                <a:cs typeface="Courier New" pitchFamily="34" charset="-120"/>
-              </a:rPr>
-              <a:t>"Function tools with reasoning_effort are not supported for gpt-5.6-luna in /v1/chat/completions."</a:t>
-            </a:r>
-            <a:endParaRPr lang="en-US" sz="1300" dirty="0"/>
-          </a:p>
-        </p:txBody>
-      </p:sp>
-      <p:sp>
-        <p:nvSpPr>
-          <p:cNvPr id="7" name="Text 5"/>
-          <p:cNvSpPr/>
-          <p:nvPr/>
-        </p:nvSpPr>
-        <p:spPr>
-          <a:xfrm>
-            <a:off x="822960" y="4480560"/>
-            <a:ext cx="10241280" cy="822960"/>
-          </a:xfrm>
-          <a:prstGeom prst="rect">
-            <a:avLst/>
-          </a:prstGeom>
-          <a:noFill/>
-          <a:ln/>
-        </p:spPr>
-        <p:txBody>
-          <a:bodyPr wrap="square" lIns="0" tIns="0" rIns="0" bIns="0" rtlCol="0" anchor="ctr"/>
-          <a:lstStyle/>
-          <a:p>
-            <a:pPr indent="0" marL="0">
-              <a:buNone/>
-            </a:pPr>
-            <a:r>
-              <a:rPr lang="en-US" sz="1500" i="1" dirty="0">
-                <a:solidFill>
-                  <a:srgbClr val="FFCF5C"/>
-                </a:solidFill>
-                <a:latin typeface="Calibri" pitchFamily="34" charset="0"/>
-                <a:ea typeface="Calibri" pitchFamily="34" charset="-122"/>
-                <a:cs typeface="Calibri" pitchFamily="34" charset="-120"/>
-              </a:rPr>
-              <a:t>Fix: request raw JSON (response_format: json_object) instead of tool-calling, and pass reasoning_effort: "none" explicitly.</a:t>
-            </a:r>
-            <a:endParaRPr lang="en-US" sz="1500" dirty="0"/>
-          </a:p>
-        </p:txBody>
-      </p:sp>
-      <p:sp>
-        <p:nvSpPr>
-          <p:cNvPr id="8" name="Text 6"/>
-          <p:cNvSpPr/>
-          <p:nvPr/>
-        </p:nvSpPr>
-        <p:spPr>
-          <a:xfrm>
-            <a:off x="457200" y="6510528"/>
-            <a:ext cx="5486400" cy="274320"/>
-          </a:xfrm>
-          <a:prstGeom prst="rect">
-            <a:avLst/>
-          </a:prstGeom>
-          <a:noFill/>
-          <a:ln/>
-        </p:spPr>
-        <p:txBody>
-          <a:bodyPr wrap="square" lIns="0" tIns="0" rIns="0" bIns="0" rtlCol="0" anchor="ctr"/>
-          <a:lstStyle/>
-          <a:p>
-            <a:pPr indent="0" marL="0">
-              <a:buNone/>
-            </a:pPr>
-            <a:r>
-              <a:rPr lang="en-US" sz="1000" dirty="0">
-                <a:solidFill>
-                  <a:srgbClr val="CFE3E8"/>
                 </a:solidFill>
                 <a:latin typeface="Calibri" pitchFamily="34" charset="0"/>
                 <a:ea typeface="Calibri" pitchFamily="34" charset="-122"/>
@@ -6394,36 +6781,14 @@
       </p:grpSpPr>
       <p:sp>
         <p:nvSpPr>
-          <p:cNvPr id="2" name="Shape 0"/>
-          <p:cNvSpPr/>
-          <p:nvPr/>
-        </p:nvSpPr>
-        <p:spPr>
-          <a:xfrm>
-            <a:off x="-1097280" y="4480560"/>
-            <a:ext cx="2926080" cy="2926080"/>
-          </a:xfrm>
-          <a:prstGeom prst="ellipse">
-            <a:avLst/>
-          </a:prstGeom>
-          <a:solidFill>
-            <a:srgbClr val="F2724B">
-              <a:alpha val="12000"/>
-            </a:srgbClr>
-          </a:solidFill>
-          <a:ln/>
-        </p:spPr>
-      </p:sp>
-      <p:sp>
-        <p:nvSpPr>
-          <p:cNvPr id="3" name="Text 1"/>
-          <p:cNvSpPr/>
-          <p:nvPr/>
-        </p:nvSpPr>
-        <p:spPr>
-          <a:xfrm>
-            <a:off x="822960" y="1005840"/>
-            <a:ext cx="9144000" cy="640080"/>
+          <p:cNvPr id="2" name="Text 0"/>
+          <p:cNvSpPr/>
+          <p:nvPr/>
+        </p:nvSpPr>
+        <p:spPr>
+          <a:xfrm>
+            <a:off x="822960" y="640080"/>
+            <a:ext cx="9601200" cy="640080"/>
           </a:xfrm>
           <a:prstGeom prst="rect">
             <a:avLst/>
@@ -6439,7 +6804,7 @@
               <a:buNone/>
             </a:pPr>
             <a:r>
-              <a:rPr lang="en-US" sz="3000" b="1" dirty="0">
+              <a:rPr lang="en-US" sz="2800" b="1" dirty="0">
                 <a:solidFill>
                   <a:srgbClr val="FFFFFF"/>
                 </a:solidFill>
@@ -6447,22 +6812,22 @@
                 <a:ea typeface="Cambria" pitchFamily="34" charset="-122"/>
                 <a:cs typeface="Cambria" pitchFamily="34" charset="-120"/>
               </a:rPr>
-              <a:t>One Honest Limitation</a:t>
-            </a:r>
-            <a:endParaRPr lang="en-US" sz="3000" dirty="0"/>
-          </a:p>
-        </p:txBody>
-      </p:sp>
-      <p:sp>
-        <p:nvSpPr>
-          <p:cNvPr id="4" name="Text 2"/>
-          <p:cNvSpPr/>
-          <p:nvPr/>
-        </p:nvSpPr>
-        <p:spPr>
-          <a:xfrm>
-            <a:off x="822960" y="1920240"/>
-            <a:ext cx="10058400" cy="914400"/>
+              <a:t>A Real Integration Bug We Hit</a:t>
+            </a:r>
+            <a:endParaRPr lang="en-US" sz="2800" dirty="0"/>
+          </a:p>
+        </p:txBody>
+      </p:sp>
+      <p:sp>
+        <p:nvSpPr>
+          <p:cNvPr id="3" name="Text 1"/>
+          <p:cNvSpPr/>
+          <p:nvPr/>
+        </p:nvSpPr>
+        <p:spPr>
+          <a:xfrm>
+            <a:off x="822960" y="1463040"/>
+            <a:ext cx="10241280" cy="640080"/>
           </a:xfrm>
           <a:prstGeom prst="rect">
             <a:avLst/>
@@ -6478,19 +6843,46 @@
               <a:buNone/>
             </a:pPr>
             <a:r>
-              <a:rPr lang="en-US" sz="2000" dirty="0">
-                <a:solidFill>
-                  <a:srgbClr val="FFCF5C"/>
+              <a:rPr lang="en-US" sz="1600" dirty="0">
+                <a:solidFill>
+                  <a:srgbClr val="CFE3E8"/>
                 </a:solidFill>
                 <a:latin typeface="Calibri" pitchFamily="34" charset="0"/>
                 <a:ea typeface="Calibri" pitchFamily="34" charset="-122"/>
                 <a:cs typeface="Calibri" pitchFamily="34" charset="-120"/>
               </a:rPr>
-              <a:t>The 3D scenes are stylized, low-poly interpretations — not photorealistic reconstructions of the real locations.</a:t>
-            </a:r>
-            <a:endParaRPr lang="en-US" sz="2000" dirty="0"/>
-          </a:p>
-        </p:txBody>
+              <a:t>gpt-5.6-luna rejects function-tool calling combined with its default reasoning_effort on /v1/chat/completions.</a:t>
+            </a:r>
+            <a:endParaRPr lang="en-US" sz="1600" dirty="0"/>
+          </a:p>
+        </p:txBody>
+      </p:sp>
+      <p:sp>
+        <p:nvSpPr>
+          <p:cNvPr id="4" name="Shape 2"/>
+          <p:cNvSpPr/>
+          <p:nvPr/>
+        </p:nvSpPr>
+        <p:spPr>
+          <a:xfrm>
+            <a:off x="822960" y="2377440"/>
+            <a:ext cx="10241280" cy="1828800"/>
+          </a:xfrm>
+          <a:prstGeom prst="roundRect">
+            <a:avLst>
+              <a:gd name="adj" fmla="val 5000"/>
+            </a:avLst>
+          </a:prstGeom>
+          <a:solidFill>
+            <a:srgbClr val="062B3D"/>
+          </a:solidFill>
+          <a:ln w="12700">
+            <a:solidFill>
+              <a:srgbClr val="0C8599"/>
+            </a:solidFill>
+            <a:prstDash val="solid"/>
+          </a:ln>
+        </p:spPr>
       </p:sp>
       <p:sp>
         <p:nvSpPr>
@@ -6500,8 +6892,8 @@
         </p:nvSpPr>
         <p:spPr>
           <a:xfrm>
-            <a:off x="822960" y="3017520"/>
-            <a:ext cx="9509760" cy="1463040"/>
+            <a:off x="1097280" y="2606040"/>
+            <a:ext cx="9692640" cy="457200"/>
           </a:xfrm>
           <a:prstGeom prst="rect">
             <a:avLst/>
@@ -6519,13 +6911,91 @@
             <a:r>
               <a:rPr lang="en-US" sz="1500" dirty="0">
                 <a:solidFill>
+                  <a:srgbClr val="F2724B"/>
+                </a:solidFill>
+                <a:latin typeface="Courier New" pitchFamily="34" charset="0"/>
+                <a:ea typeface="Courier New" pitchFamily="34" charset="-122"/>
+                <a:cs typeface="Courier New" pitchFamily="34" charset="-120"/>
+              </a:rPr>
+              <a:t>invalid_request_error — param: reasoning_effort</a:t>
+            </a:r>
+            <a:endParaRPr lang="en-US" sz="1500" dirty="0"/>
+          </a:p>
+        </p:txBody>
+      </p:sp>
+      <p:sp>
+        <p:nvSpPr>
+          <p:cNvPr id="6" name="Text 4"/>
+          <p:cNvSpPr/>
+          <p:nvPr/>
+        </p:nvSpPr>
+        <p:spPr>
+          <a:xfrm>
+            <a:off x="1097280" y="3063240"/>
+            <a:ext cx="9692640" cy="1005840"/>
+          </a:xfrm>
+          <a:prstGeom prst="rect">
+            <a:avLst/>
+          </a:prstGeom>
+          <a:noFill/>
+          <a:ln/>
+        </p:spPr>
+        <p:txBody>
+          <a:bodyPr wrap="square" lIns="0" tIns="0" rIns="0" bIns="0" rtlCol="0" anchor="ctr"/>
+          <a:lstStyle/>
+          <a:p>
+            <a:pPr indent="0" marL="0">
+              <a:buNone/>
+            </a:pPr>
+            <a:r>
+              <a:rPr lang="en-US" sz="1300" dirty="0">
+                <a:solidFill>
                   <a:srgbClr val="CFE3E8"/>
+                </a:solidFill>
+                <a:latin typeface="Courier New" pitchFamily="34" charset="0"/>
+                <a:ea typeface="Courier New" pitchFamily="34" charset="-122"/>
+                <a:cs typeface="Courier New" pitchFamily="34" charset="-120"/>
+              </a:rPr>
+              <a:t>"Function tools with reasoning_effort are not supported for gpt-5.6-luna in /v1/chat/completions."</a:t>
+            </a:r>
+            <a:endParaRPr lang="en-US" sz="1300" dirty="0"/>
+          </a:p>
+        </p:txBody>
+      </p:sp>
+      <p:sp>
+        <p:nvSpPr>
+          <p:cNvPr id="7" name="Text 5"/>
+          <p:cNvSpPr/>
+          <p:nvPr/>
+        </p:nvSpPr>
+        <p:spPr>
+          <a:xfrm>
+            <a:off x="822960" y="4480560"/>
+            <a:ext cx="10241280" cy="822960"/>
+          </a:xfrm>
+          <a:prstGeom prst="rect">
+            <a:avLst/>
+          </a:prstGeom>
+          <a:noFill/>
+          <a:ln/>
+        </p:spPr>
+        <p:txBody>
+          <a:bodyPr wrap="square" lIns="0" tIns="0" rIns="0" bIns="0" rtlCol="0" anchor="ctr"/>
+          <a:lstStyle/>
+          <a:p>
+            <a:pPr indent="0" marL="0">
+              <a:buNone/>
+            </a:pPr>
+            <a:r>
+              <a:rPr lang="en-US" sz="1500" i="1" dirty="0">
+                <a:solidFill>
+                  <a:srgbClr val="FFCF5C"/>
                 </a:solidFill>
                 <a:latin typeface="Calibri" pitchFamily="34" charset="0"/>
                 <a:ea typeface="Calibri" pitchFamily="34" charset="-122"/>
                 <a:cs typeface="Calibri" pitchFamily="34" charset="-120"/>
               </a:rPr>
-              <a:t>True 3D reconstruction needs dozens of calibrated, overlapping photos (photogrammetry / NeRF) — not review text or a handful of casual photos. We chose to be upfront about this rather than overclaim, and built a deterministic, review-grounded stylized scene instead. The token economy is the same story: presented in full, built as local state only — no real payment happens anywhere in this demo.</a:t>
+              <a:t>Fix: request raw JSON (response_format: json_object) instead of tool-calling, and pass reasoning_effort: "none" explicitly.</a:t>
             </a:r>
             <a:endParaRPr lang="en-US" sz="1500" dirty="0"/>
           </a:p>
@@ -6533,46 +7003,7 @@
       </p:sp>
       <p:sp>
         <p:nvSpPr>
-          <p:cNvPr id="6" name="Text 4"/>
-          <p:cNvSpPr/>
-          <p:nvPr/>
-        </p:nvSpPr>
-        <p:spPr>
-          <a:xfrm>
-            <a:off x="822960" y="4754880"/>
-            <a:ext cx="9509760" cy="914400"/>
-          </a:xfrm>
-          <a:prstGeom prst="rect">
-            <a:avLst/>
-          </a:prstGeom>
-          <a:noFill/>
-          <a:ln/>
-        </p:spPr>
-        <p:txBody>
-          <a:bodyPr wrap="square" lIns="0" tIns="0" rIns="0" bIns="0" rtlCol="0" anchor="ctr"/>
-          <a:lstStyle/>
-          <a:p>
-            <a:pPr indent="0" marL="0">
-              <a:buNone/>
-            </a:pPr>
-            <a:r>
-              <a:rPr lang="en-US" sz="1350" i="1" dirty="0">
-                <a:solidFill>
-                  <a:srgbClr val="9FB8B0"/>
-                </a:solidFill>
-                <a:latin typeface="Calibri" pitchFamily="34" charset="0"/>
-                <a:ea typeface="Calibri" pitchFamily="34" charset="-122"/>
-                <a:cs typeface="Calibri" pitchFamily="34" charset="-120"/>
-              </a:rPr>
-              <a:t>Also flagged: WASD movement needs a final real-browser verification pass (automated headless testing was inconclusive due to background-tab throttling).</a:t>
-            </a:r>
-            <a:endParaRPr lang="en-US" sz="1350" dirty="0"/>
-          </a:p>
-        </p:txBody>
-      </p:sp>
-      <p:sp>
-        <p:nvSpPr>
-          <p:cNvPr id="7" name="Text 5"/>
+          <p:cNvPr id="8" name="Text 6"/>
           <p:cNvSpPr/>
           <p:nvPr/>
         </p:nvSpPr>

</xml_diff>

<commit_message>
Reconcile report and deck with recaptured screenshots and fix overlaps
Recaptured screenshots after the token pricing update show Promenade des Anglais as the top-ranked example instead of Cours Saleya Market; updates every caption and prose reference in the report and deck to match. Also fixes several title/body text overlaps and stale content introduced when the deck was reformatted in Google Slides.
</commit_message>
<xml_diff>
--- a/report/Final_Presentation.pptx
+++ b/report/Final_Presentation.pptx
@@ -1958,28 +1958,6 @@
             <a:avLst/>
           </a:prstGeom>
           <a:solidFill>
-            <a:srgbClr val="FFCF5C">
-              <a:alpha val="92000"/>
-            </a:srgbClr>
-          </a:solidFill>
-          <a:ln/>
-        </p:spPr>
-      </p:sp>
-      <p:sp>
-        <p:nvSpPr>
-          <p:cNvPr id="3" name="Shape 1"/>
-          <p:cNvSpPr/>
-          <p:nvPr/>
-        </p:nvSpPr>
-        <p:spPr>
-          <a:xfrm>
-            <a:off x="9692640" y="-1188720"/>
-            <a:ext cx="3108960" cy="3108960"/>
-          </a:xfrm>
-          <a:prstGeom prst="ellipse">
-            <a:avLst/>
-          </a:prstGeom>
-          <a:solidFill>
             <a:srgbClr val="F4A300">
               <a:alpha val="85000"/>
             </a:srgbClr>
@@ -1989,7 +1967,90 @@
       </p:sp>
       <p:sp>
         <p:nvSpPr>
-          <p:cNvPr id="4" name="Text 2"/>
+          <p:cNvPr id="3" name="Shape 1"/>
+          <p:cNvSpPr/>
+          <p:nvPr/>
+        </p:nvSpPr>
+        <p:spPr>
+          <a:xfrm flipV="1">
+            <a:off x="822960" y="502920"/>
+            <a:ext cx="1920240" cy="457200"/>
+          </a:xfrm>
+          <a:prstGeom prst="line">
+            <a:avLst/>
+          </a:prstGeom>
+          <a:noFill/>
+          <a:ln w="25400">
+            <a:solidFill>
+              <a:srgbClr val="FFCF5C"/>
+            </a:solidFill>
+            <a:prstDash val="dash"/>
+          </a:ln>
+        </p:spPr>
+      </p:sp>
+      <p:sp>
+        <p:nvSpPr>
+          <p:cNvPr id="4" name="Shape 2"/>
+          <p:cNvSpPr/>
+          <p:nvPr/>
+        </p:nvSpPr>
+        <p:spPr>
+          <a:xfrm>
+            <a:off x="777240" y="914400"/>
+            <a:ext cx="91440" cy="91440"/>
+          </a:xfrm>
+          <a:prstGeom prst="ellipse">
+            <a:avLst/>
+          </a:prstGeom>
+          <a:solidFill>
+            <a:srgbClr val="FFCF5C"/>
+          </a:solidFill>
+          <a:ln/>
+        </p:spPr>
+      </p:sp>
+      <p:sp>
+        <p:nvSpPr>
+          <p:cNvPr id="5" name="Shape 3"/>
+          <p:cNvSpPr/>
+          <p:nvPr/>
+        </p:nvSpPr>
+        <p:spPr>
+          <a:xfrm>
+            <a:off x="1737360" y="685800"/>
+            <a:ext cx="91440" cy="91440"/>
+          </a:xfrm>
+          <a:prstGeom prst="ellipse">
+            <a:avLst/>
+          </a:prstGeom>
+          <a:solidFill>
+            <a:srgbClr val="FFCF5C"/>
+          </a:solidFill>
+          <a:ln/>
+        </p:spPr>
+      </p:sp>
+      <p:sp>
+        <p:nvSpPr>
+          <p:cNvPr id="6" name="Shape 4"/>
+          <p:cNvSpPr/>
+          <p:nvPr/>
+        </p:nvSpPr>
+        <p:spPr>
+          <a:xfrm rot="18300000">
+            <a:off x="2624328" y="384048"/>
+            <a:ext cx="237744" cy="237744"/>
+          </a:xfrm>
+          <a:prstGeom prst="triangle">
+            <a:avLst/>
+          </a:prstGeom>
+          <a:solidFill>
+            <a:srgbClr val="FFCF5C"/>
+          </a:solidFill>
+          <a:ln/>
+        </p:spPr>
+      </p:sp>
+      <p:sp>
+        <p:nvSpPr>
+          <p:cNvPr id="7" name="Text 5"/>
           <p:cNvSpPr/>
           <p:nvPr/>
         </p:nvSpPr>
@@ -2028,7 +2089,7 @@
       </p:sp>
       <p:sp>
         <p:nvSpPr>
-          <p:cNvPr id="5" name="Text 3"/>
+          <p:cNvPr id="8" name="Text 6"/>
           <p:cNvSpPr/>
           <p:nvPr/>
         </p:nvSpPr>
@@ -2067,7 +2128,7 @@
       </p:sp>
       <p:sp>
         <p:nvSpPr>
-          <p:cNvPr id="6" name="Text 4"/>
+          <p:cNvPr id="9" name="Text 7"/>
           <p:cNvSpPr/>
           <p:nvPr/>
         </p:nvSpPr>
@@ -2106,7 +2167,7 @@
       </p:sp>
       <p:sp>
         <p:nvSpPr>
-          <p:cNvPr id="7" name="Text 5"/>
+          <p:cNvPr id="10" name="Text 8"/>
           <p:cNvSpPr/>
           <p:nvPr/>
         </p:nvSpPr>
@@ -2145,7 +2206,7 @@
       </p:sp>
       <p:sp>
         <p:nvSpPr>
-          <p:cNvPr id="8" name="Text 6"/>
+          <p:cNvPr id="11" name="Text 9"/>
           <p:cNvSpPr/>
           <p:nvPr/>
         </p:nvSpPr>
@@ -2184,7 +2245,7 @@
       </p:sp>
       <p:sp>
         <p:nvSpPr>
-          <p:cNvPr id="9" name="Text 7"/>
+          <p:cNvPr id="12" name="Text 10"/>
           <p:cNvSpPr/>
           <p:nvPr/>
         </p:nvSpPr>
@@ -2223,7 +2284,7 @@
       </p:sp>
       <p:sp>
         <p:nvSpPr>
-          <p:cNvPr id="10" name="Text 8"/>
+          <p:cNvPr id="13" name="Text 11"/>
           <p:cNvSpPr/>
           <p:nvPr/>
         </p:nvSpPr>
@@ -2543,14 +2604,54 @@
       </p:grpSpPr>
       <p:sp>
         <p:nvSpPr>
-          <p:cNvPr id="2" name="Text 0"/>
-          <p:cNvSpPr/>
-          <p:nvPr/>
-        </p:nvSpPr>
-        <p:spPr>
-          <a:xfrm>
-            <a:off x="822960" y="457200"/>
-            <a:ext cx="10058400" cy="548640"/>
+          <p:cNvPr id="2" name="Shape 0"/>
+          <p:cNvSpPr/>
+          <p:nvPr/>
+        </p:nvSpPr>
+        <p:spPr>
+          <a:xfrm>
+            <a:off x="822960" y="438912"/>
+            <a:ext cx="457200" cy="457200"/>
+          </a:xfrm>
+          <a:prstGeom prst="ellipse">
+            <a:avLst/>
+          </a:prstGeom>
+          <a:solidFill>
+            <a:srgbClr val="F4A300"/>
+          </a:solidFill>
+          <a:ln/>
+        </p:spPr>
+      </p:sp>
+      <p:sp>
+        <p:nvSpPr>
+          <p:cNvPr id="3" name="Shape 1"/>
+          <p:cNvSpPr/>
+          <p:nvPr/>
+        </p:nvSpPr>
+        <p:spPr>
+          <a:xfrm>
+            <a:off x="932688" y="548640"/>
+            <a:ext cx="237744" cy="237744"/>
+          </a:xfrm>
+          <a:prstGeom prst="star5">
+            <a:avLst/>
+          </a:prstGeom>
+          <a:solidFill>
+            <a:srgbClr val="FFFFFF"/>
+          </a:solidFill>
+          <a:ln/>
+        </p:spPr>
+      </p:sp>
+      <p:sp>
+        <p:nvSpPr>
+          <p:cNvPr id="4" name="Text 2"/>
+          <p:cNvSpPr/>
+          <p:nvPr/>
+        </p:nvSpPr>
+        <p:spPr>
+          <a:xfrm>
+            <a:off x="1417320" y="438912"/>
+            <a:ext cx="9601200" cy="548640"/>
           </a:xfrm>
           <a:prstGeom prst="rect">
             <a:avLst/>
@@ -2582,13 +2683,13 @@
       </p:sp>
       <p:sp>
         <p:nvSpPr>
-          <p:cNvPr id="3" name="Text 1"/>
-          <p:cNvSpPr/>
-          <p:nvPr/>
-        </p:nvSpPr>
-        <p:spPr>
-          <a:xfrm>
-            <a:off x="822960" y="1005840"/>
+          <p:cNvPr id="5" name="Text 3"/>
+          <p:cNvSpPr/>
+          <p:nvPr/>
+        </p:nvSpPr>
+        <p:spPr>
+          <a:xfrm>
+            <a:off x="822960" y="1051560"/>
             <a:ext cx="10241280" cy="365760"/>
           </a:xfrm>
           <a:prstGeom prst="rect">
@@ -2634,7 +2735,7 @@
           </p:nvPr>
         </p:nvGraphicFramePr>
         <p:xfrm>
-          <a:off x="822960" y="1600200"/>
+          <a:off x="822960" y="1645920"/>
           <a:ext cx="6583680" cy="914400"/>
         </p:xfrm>
         <a:graphic>
@@ -3479,13 +3580,13 @@
       </p:graphicFrame>
       <p:sp>
         <p:nvSpPr>
-          <p:cNvPr id="5" name="Shape 2"/>
-          <p:cNvSpPr/>
-          <p:nvPr/>
-        </p:nvSpPr>
-        <p:spPr>
-          <a:xfrm>
-            <a:off x="7772400" y="1600200"/>
+          <p:cNvPr id="7" name="Shape 4"/>
+          <p:cNvSpPr/>
+          <p:nvPr/>
+        </p:nvSpPr>
+        <p:spPr>
+          <a:xfrm>
+            <a:off x="7772400" y="1645920"/>
             <a:ext cx="3566160" cy="3017520"/>
           </a:xfrm>
           <a:prstGeom prst="roundRect">
@@ -3508,13 +3609,13 @@
       </p:sp>
       <p:sp>
         <p:nvSpPr>
-          <p:cNvPr id="6" name="Text 3"/>
-          <p:cNvSpPr/>
-          <p:nvPr/>
-        </p:nvSpPr>
-        <p:spPr>
-          <a:xfrm>
-            <a:off x="8046720" y="1783080"/>
+          <p:cNvPr id="8" name="Text 5"/>
+          <p:cNvSpPr/>
+          <p:nvPr/>
+        </p:nvSpPr>
+        <p:spPr>
+          <a:xfrm>
+            <a:off x="8046720" y="1828800"/>
             <a:ext cx="3017520" cy="411480"/>
           </a:xfrm>
           <a:prstGeom prst="rect">
@@ -3547,13 +3648,13 @@
       </p:sp>
       <p:sp>
         <p:nvSpPr>
-          <p:cNvPr id="7" name="Text 4"/>
-          <p:cNvSpPr/>
-          <p:nvPr/>
-        </p:nvSpPr>
-        <p:spPr>
-          <a:xfrm>
-            <a:off x="8046720" y="2286000"/>
+          <p:cNvPr id="9" name="Text 6"/>
+          <p:cNvSpPr/>
+          <p:nvPr/>
+        </p:nvSpPr>
+        <p:spPr>
+          <a:xfrm>
+            <a:off x="8046720" y="2331720"/>
             <a:ext cx="3017520" cy="2194560"/>
           </a:xfrm>
           <a:prstGeom prst="rect">
@@ -3586,7 +3687,7 @@
       </p:sp>
       <p:sp>
         <p:nvSpPr>
-          <p:cNvPr id="8" name="Text 5"/>
+          <p:cNvPr id="10" name="Text 7"/>
           <p:cNvSpPr/>
           <p:nvPr/>
         </p:nvSpPr>
@@ -3663,7 +3764,7 @@
         </p:nvSpPr>
         <p:spPr>
           <a:xfrm>
-            <a:off x="822960" y="548640"/>
+            <a:off x="822960" y="502920"/>
             <a:ext cx="7315200" cy="640080"/>
           </a:xfrm>
           <a:prstGeom prst="rect">
@@ -3702,12 +3803,12 @@
         </p:nvSpPr>
         <p:spPr>
           <a:xfrm>
-            <a:off x="822960" y="1371600"/>
-            <a:ext cx="10241280" cy="1691640"/>
+            <a:off x="822960" y="1280160"/>
+            <a:ext cx="10241280" cy="1554480"/>
           </a:xfrm>
           <a:prstGeom prst="roundRect">
             <a:avLst>
-              <a:gd name="adj" fmla="val 5405"/>
+              <a:gd name="adj" fmla="val 5882"/>
             </a:avLst>
           </a:prstGeom>
           <a:solidFill>
@@ -3725,14 +3826,54 @@
       </p:sp>
       <p:sp>
         <p:nvSpPr>
-          <p:cNvPr id="4" name="Text 2"/>
-          <p:cNvSpPr/>
-          <p:nvPr/>
-        </p:nvSpPr>
-        <p:spPr>
-          <a:xfrm>
-            <a:off x="1097280" y="1554480"/>
-            <a:ext cx="9692640" cy="411480"/>
+          <p:cNvPr id="4" name="Shape 2"/>
+          <p:cNvSpPr/>
+          <p:nvPr/>
+        </p:nvSpPr>
+        <p:spPr>
+          <a:xfrm>
+            <a:off x="1051560" y="1463040"/>
+            <a:ext cx="438912" cy="438912"/>
+          </a:xfrm>
+          <a:prstGeom prst="ellipse">
+            <a:avLst/>
+          </a:prstGeom>
+          <a:solidFill>
+            <a:srgbClr val="F4A300"/>
+          </a:solidFill>
+          <a:ln/>
+        </p:spPr>
+      </p:sp>
+      <p:sp>
+        <p:nvSpPr>
+          <p:cNvPr id="5" name="Shape 3"/>
+          <p:cNvSpPr/>
+          <p:nvPr/>
+        </p:nvSpPr>
+        <p:spPr>
+          <a:xfrm>
+            <a:off x="1156899" y="1568379"/>
+            <a:ext cx="228234" cy="228234"/>
+          </a:xfrm>
+          <a:prstGeom prst="star5">
+            <a:avLst/>
+          </a:prstGeom>
+          <a:solidFill>
+            <a:srgbClr val="FFFFFF"/>
+          </a:solidFill>
+          <a:ln/>
+        </p:spPr>
+      </p:sp>
+      <p:sp>
+        <p:nvSpPr>
+          <p:cNvPr id="6" name="Text 4"/>
+          <p:cNvSpPr/>
+          <p:nvPr/>
+        </p:nvSpPr>
+        <p:spPr>
+          <a:xfrm>
+            <a:off x="1645920" y="1463040"/>
+            <a:ext cx="9235440" cy="411480"/>
           </a:xfrm>
           <a:prstGeom prst="rect">
             <a:avLst/>
@@ -3764,14 +3905,14 @@
       </p:sp>
       <p:sp>
         <p:nvSpPr>
-          <p:cNvPr id="5" name="Text 3"/>
-          <p:cNvSpPr/>
-          <p:nvPr/>
-        </p:nvSpPr>
-        <p:spPr>
-          <a:xfrm>
-            <a:off x="1097280" y="1965960"/>
-            <a:ext cx="9692640" cy="1005840"/>
+          <p:cNvPr id="7" name="Text 5"/>
+          <p:cNvSpPr/>
+          <p:nvPr/>
+        </p:nvSpPr>
+        <p:spPr>
+          <a:xfrm>
+            <a:off x="1097280" y="1920240"/>
+            <a:ext cx="9692640" cy="868680"/>
           </a:xfrm>
           <a:prstGeom prst="rect">
             <a:avLst/>
@@ -3787,7 +3928,7 @@
               <a:buNone/>
             </a:pPr>
             <a:r>
-              <a:rPr lang="en-US" sz="1350" dirty="0">
+              <a:rPr lang="en-US" sz="1300" dirty="0">
                 <a:solidFill>
                   <a:srgbClr val="FFFFFF"/>
                 </a:solidFill>
@@ -3797,40 +3938,84 @@
               </a:rPr>
               <a:t>Travelers upload up to 3 of their own photos per spot -&gt; vision model extracts richer ambiance -&gt; traveler earns a real 30-token reward per spot. Fully legitimate (user-submitted, not scraped). Needs accounts, storage, and moderation — a real backend, deliberately out of scope for now.</a:t>
             </a:r>
-            <a:endParaRPr lang="en-US" sz="1350" dirty="0"/>
-          </a:p>
-        </p:txBody>
-      </p:sp>
-      <p:sp>
-        <p:nvSpPr>
-          <p:cNvPr id="6" name="Text 4"/>
-          <p:cNvSpPr/>
-          <p:nvPr/>
-        </p:nvSpPr>
-        <p:spPr>
-          <a:xfrm>
-            <a:off x="822960" y="3383280"/>
-            <a:ext cx="10058400" cy="2651760"/>
-          </a:xfrm>
-          <a:prstGeom prst="rect">
+            <a:endParaRPr lang="en-US" sz="1300" dirty="0"/>
+          </a:p>
+        </p:txBody>
+      </p:sp>
+      <p:sp>
+        <p:nvSpPr>
+          <p:cNvPr id="8" name="Shape 6"/>
+          <p:cNvSpPr/>
+          <p:nvPr/>
+        </p:nvSpPr>
+        <p:spPr>
+          <a:xfrm>
+            <a:off x="1188720" y="4709160"/>
+            <a:ext cx="9784080" cy="914"/>
+          </a:xfrm>
+          <a:prstGeom prst="line">
             <a:avLst/>
           </a:prstGeom>
           <a:noFill/>
-          <a:ln/>
-        </p:spPr>
-        <p:txBody>
-          <a:bodyPr wrap="square" lIns="0" tIns="0" rIns="0" bIns="0" rtlCol="0" anchor="ctr"/>
-          <a:lstStyle/>
-          <a:p>
-            <a:pPr marL="342900" indent="-342900">
-              <a:spcAft>
-                <a:spcPts val="1000"/>
-              </a:spcAft>
-              <a:buSzPct val="100000"/>
-              <a:buChar char="•"/>
-            </a:pPr>
-            <a:r>
-              <a:rPr lang="en-US" sz="1400" dirty="0">
+          <a:ln w="25400">
+            <a:solidFill>
+              <a:srgbClr val="FFCF5C"/>
+            </a:solidFill>
+            <a:prstDash val="dash"/>
+          </a:ln>
+        </p:spPr>
+      </p:sp>
+      <p:sp>
+        <p:nvSpPr>
+          <p:cNvPr id="9" name="Shape 7"/>
+          <p:cNvSpPr/>
+          <p:nvPr/>
+        </p:nvSpPr>
+        <p:spPr>
+          <a:xfrm>
+            <a:off x="1124712" y="4645152"/>
+            <a:ext cx="128016" cy="128016"/>
+          </a:xfrm>
+          <a:prstGeom prst="ellipse">
+            <a:avLst/>
+          </a:prstGeom>
+          <a:solidFill>
+            <a:srgbClr val="F4A300"/>
+          </a:solidFill>
+          <a:ln w="15875">
+            <a:solidFill>
+              <a:srgbClr val="FFFFFF"/>
+            </a:solidFill>
+            <a:prstDash val="solid"/>
+          </a:ln>
+        </p:spPr>
+      </p:sp>
+      <p:sp>
+        <p:nvSpPr>
+          <p:cNvPr id="10" name="Text 8"/>
+          <p:cNvSpPr/>
+          <p:nvPr/>
+        </p:nvSpPr>
+        <p:spPr>
+          <a:xfrm>
+            <a:off x="228600" y="3931920"/>
+            <a:ext cx="1920240" cy="594360"/>
+          </a:xfrm>
+          <a:prstGeom prst="rect">
+            <a:avLst/>
+          </a:prstGeom>
+          <a:noFill/>
+          <a:ln/>
+        </p:spPr>
+        <p:txBody>
+          <a:bodyPr wrap="square" lIns="0" tIns="0" rIns="0" bIns="0" rtlCol="0" anchor="b"/>
+          <a:lstStyle/>
+          <a:p>
+            <a:pPr algn="ctr" indent="0" marL="0">
+              <a:buNone/>
+            </a:pPr>
+            <a:r>
+              <a:rPr lang="en-US" sz="1150" dirty="0">
                 <a:solidFill>
                   <a:srgbClr val="CFE3E8"/>
                 </a:solidFill>
@@ -3838,20 +4023,63 @@
                 <a:ea typeface="Calibri" pitchFamily="34" charset="-122"/>
                 <a:cs typeface="Calibri" pitchFamily="34" charset="-120"/>
               </a:rPr>
-              <a:t>Real payment processing and persistent accounts for the token economy</a:t>
-            </a:r>
-            <a:endParaRPr lang="en-US" sz="1400" dirty="0"/>
-          </a:p>
-          <a:p>
-            <a:pPr marL="342900" indent="-342900">
-              <a:spcAft>
-                <a:spcPts val="1000"/>
-              </a:spcAft>
-              <a:buSzPct val="100000"/>
-              <a:buChar char="•"/>
-            </a:pPr>
-            <a:r>
-              <a:rPr lang="en-US" sz="1400" dirty="0">
+              <a:t>Real payments</a:t>
+            </a:r>
+            <a:endParaRPr lang="en-US" sz="1150" dirty="0"/>
+          </a:p>
+        </p:txBody>
+      </p:sp>
+      <p:sp>
+        <p:nvSpPr>
+          <p:cNvPr id="11" name="Shape 9"/>
+          <p:cNvSpPr/>
+          <p:nvPr/>
+        </p:nvSpPr>
+        <p:spPr>
+          <a:xfrm>
+            <a:off x="3081528" y="4645152"/>
+            <a:ext cx="128016" cy="128016"/>
+          </a:xfrm>
+          <a:prstGeom prst="ellipse">
+            <a:avLst/>
+          </a:prstGeom>
+          <a:solidFill>
+            <a:srgbClr val="F4A300"/>
+          </a:solidFill>
+          <a:ln w="15875">
+            <a:solidFill>
+              <a:srgbClr val="FFFFFF"/>
+            </a:solidFill>
+            <a:prstDash val="solid"/>
+          </a:ln>
+        </p:spPr>
+      </p:sp>
+      <p:sp>
+        <p:nvSpPr>
+          <p:cNvPr id="12" name="Text 10"/>
+          <p:cNvSpPr/>
+          <p:nvPr/>
+        </p:nvSpPr>
+        <p:spPr>
+          <a:xfrm>
+            <a:off x="2185416" y="4910328"/>
+            <a:ext cx="1920240" cy="594360"/>
+          </a:xfrm>
+          <a:prstGeom prst="rect">
+            <a:avLst/>
+          </a:prstGeom>
+          <a:noFill/>
+          <a:ln/>
+        </p:spPr>
+        <p:txBody>
+          <a:bodyPr wrap="square" lIns="0" tIns="0" rIns="0" bIns="0" rtlCol="0" anchor="t"/>
+          <a:lstStyle/>
+          <a:p>
+            <a:pPr algn="ctr" indent="0" marL="0">
+              <a:buNone/>
+            </a:pPr>
+            <a:r>
+              <a:rPr lang="en-US" sz="1150" dirty="0">
                 <a:solidFill>
                   <a:srgbClr val="CFE3E8"/>
                 </a:solidFill>
@@ -3859,20 +4087,63 @@
                 <a:ea typeface="Calibri" pitchFamily="34" charset="-122"/>
                 <a:cs typeface="Calibri" pitchFamily="34" charset="-120"/>
               </a:rPr>
-              <a:t>Move the OpenAI call server-side before any public deployment</a:t>
-            </a:r>
-            <a:endParaRPr lang="en-US" sz="1400" dirty="0"/>
-          </a:p>
-          <a:p>
-            <a:pPr marL="342900" indent="-342900">
-              <a:spcAft>
-                <a:spcPts val="1000"/>
-              </a:spcAft>
-              <a:buSzPct val="100000"/>
-              <a:buChar char="•"/>
-            </a:pPr>
-            <a:r>
-              <a:rPr lang="en-US" sz="1400" dirty="0">
+              <a:t>Server-side API key</a:t>
+            </a:r>
+            <a:endParaRPr lang="en-US" sz="1150" dirty="0"/>
+          </a:p>
+        </p:txBody>
+      </p:sp>
+      <p:sp>
+        <p:nvSpPr>
+          <p:cNvPr id="13" name="Shape 11"/>
+          <p:cNvSpPr/>
+          <p:nvPr/>
+        </p:nvSpPr>
+        <p:spPr>
+          <a:xfrm>
+            <a:off x="5038344" y="4645152"/>
+            <a:ext cx="128016" cy="128016"/>
+          </a:xfrm>
+          <a:prstGeom prst="ellipse">
+            <a:avLst/>
+          </a:prstGeom>
+          <a:solidFill>
+            <a:srgbClr val="F4A300"/>
+          </a:solidFill>
+          <a:ln w="15875">
+            <a:solidFill>
+              <a:srgbClr val="FFFFFF"/>
+            </a:solidFill>
+            <a:prstDash val="solid"/>
+          </a:ln>
+        </p:spPr>
+      </p:sp>
+      <p:sp>
+        <p:nvSpPr>
+          <p:cNvPr id="14" name="Text 12"/>
+          <p:cNvSpPr/>
+          <p:nvPr/>
+        </p:nvSpPr>
+        <p:spPr>
+          <a:xfrm>
+            <a:off x="4142232" y="3931920"/>
+            <a:ext cx="1920240" cy="594360"/>
+          </a:xfrm>
+          <a:prstGeom prst="rect">
+            <a:avLst/>
+          </a:prstGeom>
+          <a:noFill/>
+          <a:ln/>
+        </p:spPr>
+        <p:txBody>
+          <a:bodyPr wrap="square" lIns="0" tIns="0" rIns="0" bIns="0" rtlCol="0" anchor="b"/>
+          <a:lstStyle/>
+          <a:p>
+            <a:pPr algn="ctr" indent="0" marL="0">
+              <a:buNone/>
+            </a:pPr>
+            <a:r>
+              <a:rPr lang="en-US" sz="1150" dirty="0">
                 <a:solidFill>
                   <a:srgbClr val="CFE3E8"/>
                 </a:solidFill>
@@ -3880,20 +4151,63 @@
                 <a:ea typeface="Calibri" pitchFamily="34" charset="-122"/>
                 <a:cs typeface="Calibri" pitchFamily="34" charset="-120"/>
               </a:rPr>
-              <a:t>Hotel, flight, and other token-gated booking add-ons</a:t>
-            </a:r>
-            <a:endParaRPr lang="en-US" sz="1400" dirty="0"/>
-          </a:p>
-          <a:p>
-            <a:pPr marL="342900" indent="-342900">
-              <a:spcAft>
-                <a:spcPts val="1000"/>
-              </a:spcAft>
-              <a:buSzPct val="100000"/>
-              <a:buChar char="•"/>
-            </a:pPr>
-            <a:r>
-              <a:rPr lang="en-US" sz="1400" dirty="0">
+              <a:t>Booking add-ons</a:t>
+            </a:r>
+            <a:endParaRPr lang="en-US" sz="1150" dirty="0"/>
+          </a:p>
+        </p:txBody>
+      </p:sp>
+      <p:sp>
+        <p:nvSpPr>
+          <p:cNvPr id="15" name="Shape 13"/>
+          <p:cNvSpPr/>
+          <p:nvPr/>
+        </p:nvSpPr>
+        <p:spPr>
+          <a:xfrm>
+            <a:off x="6995160" y="4645152"/>
+            <a:ext cx="128016" cy="128016"/>
+          </a:xfrm>
+          <a:prstGeom prst="ellipse">
+            <a:avLst/>
+          </a:prstGeom>
+          <a:solidFill>
+            <a:srgbClr val="F4A300"/>
+          </a:solidFill>
+          <a:ln w="15875">
+            <a:solidFill>
+              <a:srgbClr val="FFFFFF"/>
+            </a:solidFill>
+            <a:prstDash val="solid"/>
+          </a:ln>
+        </p:spPr>
+      </p:sp>
+      <p:sp>
+        <p:nvSpPr>
+          <p:cNvPr id="16" name="Text 14"/>
+          <p:cNvSpPr/>
+          <p:nvPr/>
+        </p:nvSpPr>
+        <p:spPr>
+          <a:xfrm>
+            <a:off x="6099048" y="4910328"/>
+            <a:ext cx="1920240" cy="594360"/>
+          </a:xfrm>
+          <a:prstGeom prst="rect">
+            <a:avLst/>
+          </a:prstGeom>
+          <a:noFill/>
+          <a:ln/>
+        </p:spPr>
+        <p:txBody>
+          <a:bodyPr wrap="square" lIns="0" tIns="0" rIns="0" bIns="0" rtlCol="0" anchor="t"/>
+          <a:lstStyle/>
+          <a:p>
+            <a:pPr algn="ctr" indent="0" marL="0">
+              <a:buNone/>
+            </a:pPr>
+            <a:r>
+              <a:rPr lang="en-US" sz="1150" dirty="0">
                 <a:solidFill>
                   <a:srgbClr val="CFE3E8"/>
                 </a:solidFill>
@@ -3901,20 +4215,63 @@
                 <a:ea typeface="Calibri" pitchFamily="34" charset="-122"/>
                 <a:cs typeface="Calibri" pitchFamily="34" charset="-120"/>
               </a:rPr>
-              <a:t>Expand beyond Nice to more destinations</a:t>
-            </a:r>
-            <a:endParaRPr lang="en-US" sz="1400" dirty="0"/>
-          </a:p>
-          <a:p>
-            <a:pPr marL="342900" indent="-342900">
-              <a:spcAft>
-                <a:spcPts val="1000"/>
-              </a:spcAft>
-              <a:buSzPct val="100000"/>
-              <a:buChar char="•"/>
-            </a:pPr>
-            <a:r>
-              <a:rPr lang="en-US" sz="1400" dirty="0">
+              <a:t>More destinations</a:t>
+            </a:r>
+            <a:endParaRPr lang="en-US" sz="1150" dirty="0"/>
+          </a:p>
+        </p:txBody>
+      </p:sp>
+      <p:sp>
+        <p:nvSpPr>
+          <p:cNvPr id="17" name="Shape 15"/>
+          <p:cNvSpPr/>
+          <p:nvPr/>
+        </p:nvSpPr>
+        <p:spPr>
+          <a:xfrm>
+            <a:off x="8951976" y="4645152"/>
+            <a:ext cx="128016" cy="128016"/>
+          </a:xfrm>
+          <a:prstGeom prst="ellipse">
+            <a:avLst/>
+          </a:prstGeom>
+          <a:solidFill>
+            <a:srgbClr val="F4A300"/>
+          </a:solidFill>
+          <a:ln w="15875">
+            <a:solidFill>
+              <a:srgbClr val="FFFFFF"/>
+            </a:solidFill>
+            <a:prstDash val="solid"/>
+          </a:ln>
+        </p:spPr>
+      </p:sp>
+      <p:sp>
+        <p:nvSpPr>
+          <p:cNvPr id="18" name="Text 16"/>
+          <p:cNvSpPr/>
+          <p:nvPr/>
+        </p:nvSpPr>
+        <p:spPr>
+          <a:xfrm>
+            <a:off x="8055864" y="3931920"/>
+            <a:ext cx="1920240" cy="594360"/>
+          </a:xfrm>
+          <a:prstGeom prst="rect">
+            <a:avLst/>
+          </a:prstGeom>
+          <a:noFill/>
+          <a:ln/>
+        </p:spPr>
+        <p:txBody>
+          <a:bodyPr wrap="square" lIns="0" tIns="0" rIns="0" bIns="0" rtlCol="0" anchor="b"/>
+          <a:lstStyle/>
+          <a:p>
+            <a:pPr algn="ctr" indent="0" marL="0">
+              <a:buNone/>
+            </a:pPr>
+            <a:r>
+              <a:rPr lang="en-US" sz="1150" dirty="0">
                 <a:solidFill>
                   <a:srgbClr val="CFE3E8"/>
                 </a:solidFill>
@@ -3922,20 +4279,63 @@
                 <a:ea typeface="Calibri" pitchFamily="34" charset="-122"/>
                 <a:cs typeface="Calibri" pitchFamily="34" charset="-120"/>
               </a:rPr>
-              <a:t>Touch controls for mobile (today assumes a keyboard)</a:t>
-            </a:r>
-            <a:endParaRPr lang="en-US" sz="1400" dirty="0"/>
-          </a:p>
-          <a:p>
-            <a:pPr marL="342900" indent="-342900">
-              <a:spcAft>
-                <a:spcPts val="1000"/>
-              </a:spcAft>
-              <a:buSzPct val="100000"/>
-              <a:buChar char="•"/>
-            </a:pPr>
-            <a:r>
-              <a:rPr lang="en-US" sz="1400" dirty="0">
+              <a:t>Mobile controls</a:t>
+            </a:r>
+            <a:endParaRPr lang="en-US" sz="1150" dirty="0"/>
+          </a:p>
+        </p:txBody>
+      </p:sp>
+      <p:sp>
+        <p:nvSpPr>
+          <p:cNvPr id="19" name="Shape 17"/>
+          <p:cNvSpPr/>
+          <p:nvPr/>
+        </p:nvSpPr>
+        <p:spPr>
+          <a:xfrm>
+            <a:off x="10908792" y="4645152"/>
+            <a:ext cx="128016" cy="128016"/>
+          </a:xfrm>
+          <a:prstGeom prst="ellipse">
+            <a:avLst/>
+          </a:prstGeom>
+          <a:solidFill>
+            <a:srgbClr val="F4A300"/>
+          </a:solidFill>
+          <a:ln w="15875">
+            <a:solidFill>
+              <a:srgbClr val="FFFFFF"/>
+            </a:solidFill>
+            <a:prstDash val="solid"/>
+          </a:ln>
+        </p:spPr>
+      </p:sp>
+      <p:sp>
+        <p:nvSpPr>
+          <p:cNvPr id="20" name="Text 18"/>
+          <p:cNvSpPr/>
+          <p:nvPr/>
+        </p:nvSpPr>
+        <p:spPr>
+          <a:xfrm>
+            <a:off x="10012680" y="4910328"/>
+            <a:ext cx="1920240" cy="594360"/>
+          </a:xfrm>
+          <a:prstGeom prst="rect">
+            <a:avLst/>
+          </a:prstGeom>
+          <a:noFill/>
+          <a:ln/>
+        </p:spPr>
+        <p:txBody>
+          <a:bodyPr wrap="square" lIns="0" tIns="0" rIns="0" bIns="0" rtlCol="0" anchor="t"/>
+          <a:lstStyle/>
+          <a:p>
+            <a:pPr algn="ctr" indent="0" marL="0">
+              <a:buNone/>
+            </a:pPr>
+            <a:r>
+              <a:rPr lang="en-US" sz="1150" dirty="0">
                 <a:solidFill>
                   <a:srgbClr val="CFE3E8"/>
                 </a:solidFill>
@@ -3943,15 +4343,54 @@
                 <a:ea typeface="Calibri" pitchFamily="34" charset="-122"/>
                 <a:cs typeface="Calibri" pitchFamily="34" charset="-120"/>
               </a:rPr>
-              <a:t>A real usability study outside the two-person team</a:t>
-            </a:r>
-            <a:endParaRPr lang="en-US" sz="1400" dirty="0"/>
-          </a:p>
-        </p:txBody>
-      </p:sp>
-      <p:sp>
-        <p:nvSpPr>
-          <p:cNvPr id="7" name="Text 5"/>
+              <a:t>Usability study</a:t>
+            </a:r>
+            <a:endParaRPr lang="en-US" sz="1150" dirty="0"/>
+          </a:p>
+        </p:txBody>
+      </p:sp>
+      <p:sp>
+        <p:nvSpPr>
+          <p:cNvPr id="21" name="Text 19"/>
+          <p:cNvSpPr/>
+          <p:nvPr/>
+        </p:nvSpPr>
+        <p:spPr>
+          <a:xfrm>
+            <a:off x="822960" y="5989320"/>
+            <a:ext cx="5486400" cy="365760"/>
+          </a:xfrm>
+          <a:prstGeom prst="rect">
+            <a:avLst/>
+          </a:prstGeom>
+          <a:noFill/>
+          <a:ln/>
+        </p:spPr>
+        <p:txBody>
+          <a:bodyPr wrap="square" lIns="0" tIns="0" rIns="0" bIns="0" rtlCol="0" anchor="ctr"/>
+          <a:lstStyle/>
+          <a:p>
+            <a:pPr indent="0" marL="0">
+              <a:buNone/>
+            </a:pPr>
+            <a:r>
+              <a:rPr lang="en-US" sz="1100" i="1" dirty="0">
+                <a:solidFill>
+                  <a:srgbClr val="9FB8B0"/>
+                </a:solidFill>
+                <a:latin typeface="Calibri" pitchFamily="34" charset="0"/>
+                <a:ea typeface="Calibri" pitchFamily="34" charset="-122"/>
+                <a:cs typeface="Calibri" pitchFamily="34" charset="-120"/>
+              </a:rPr>
+              <a:t>Roadmap timeline (details in the report)</a:t>
+            </a:r>
+            <a:endParaRPr lang="en-US" sz="1100" dirty="0"/>
+          </a:p>
+        </p:txBody>
+      </p:sp>
+      <p:sp>
+        <p:nvSpPr>
+          <p:cNvPr id="22" name="Text 20"/>
           <p:cNvSpPr/>
           <p:nvPr/>
         </p:nvSpPr>
@@ -4035,28 +4474,6 @@
             <a:avLst/>
           </a:prstGeom>
           <a:solidFill>
-            <a:srgbClr val="FFCF5C">
-              <a:alpha val="92000"/>
-            </a:srgbClr>
-          </a:solidFill>
-          <a:ln/>
-        </p:spPr>
-      </p:sp>
-      <p:sp>
-        <p:nvSpPr>
-          <p:cNvPr id="3" name="Shape 1"/>
-          <p:cNvSpPr/>
-          <p:nvPr/>
-        </p:nvSpPr>
-        <p:spPr>
-          <a:xfrm>
-            <a:off x="9692640" y="4206240"/>
-            <a:ext cx="3108960" cy="3108960"/>
-          </a:xfrm>
-          <a:prstGeom prst="ellipse">
-            <a:avLst/>
-          </a:prstGeom>
-          <a:solidFill>
             <a:srgbClr val="F4A300">
               <a:alpha val="85000"/>
             </a:srgbClr>
@@ -4066,7 +4483,90 @@
       </p:sp>
       <p:sp>
         <p:nvSpPr>
-          <p:cNvPr id="4" name="Text 2"/>
+          <p:cNvPr id="3" name="Shape 1"/>
+          <p:cNvSpPr/>
+          <p:nvPr/>
+        </p:nvSpPr>
+        <p:spPr>
+          <a:xfrm flipV="1">
+            <a:off x="7863840" y="5349240"/>
+            <a:ext cx="1920240" cy="777240"/>
+          </a:xfrm>
+          <a:prstGeom prst="line">
+            <a:avLst/>
+          </a:prstGeom>
+          <a:noFill/>
+          <a:ln w="25400">
+            <a:solidFill>
+              <a:srgbClr val="FFCF5C"/>
+            </a:solidFill>
+            <a:prstDash val="dash"/>
+          </a:ln>
+        </p:spPr>
+      </p:sp>
+      <p:sp>
+        <p:nvSpPr>
+          <p:cNvPr id="4" name="Shape 2"/>
+          <p:cNvSpPr/>
+          <p:nvPr/>
+        </p:nvSpPr>
+        <p:spPr>
+          <a:xfrm>
+            <a:off x="7818120" y="6080760"/>
+            <a:ext cx="91440" cy="91440"/>
+          </a:xfrm>
+          <a:prstGeom prst="ellipse">
+            <a:avLst/>
+          </a:prstGeom>
+          <a:solidFill>
+            <a:srgbClr val="FFCF5C"/>
+          </a:solidFill>
+          <a:ln/>
+        </p:spPr>
+      </p:sp>
+      <p:sp>
+        <p:nvSpPr>
+          <p:cNvPr id="5" name="Shape 3"/>
+          <p:cNvSpPr/>
+          <p:nvPr/>
+        </p:nvSpPr>
+        <p:spPr>
+          <a:xfrm>
+            <a:off x="8778240" y="5692140"/>
+            <a:ext cx="91440" cy="91440"/>
+          </a:xfrm>
+          <a:prstGeom prst="ellipse">
+            <a:avLst/>
+          </a:prstGeom>
+          <a:solidFill>
+            <a:srgbClr val="FFCF5C"/>
+          </a:solidFill>
+          <a:ln/>
+        </p:spPr>
+      </p:sp>
+      <p:sp>
+        <p:nvSpPr>
+          <p:cNvPr id="6" name="Shape 4"/>
+          <p:cNvSpPr/>
+          <p:nvPr/>
+        </p:nvSpPr>
+        <p:spPr>
+          <a:xfrm rot="18300000">
+            <a:off x="9665208" y="5230368"/>
+            <a:ext cx="237744" cy="237744"/>
+          </a:xfrm>
+          <a:prstGeom prst="triangle">
+            <a:avLst/>
+          </a:prstGeom>
+          <a:solidFill>
+            <a:srgbClr val="FFCF5C"/>
+          </a:solidFill>
+          <a:ln/>
+        </p:spPr>
+      </p:sp>
+      <p:sp>
+        <p:nvSpPr>
+          <p:cNvPr id="7" name="Text 5"/>
           <p:cNvSpPr/>
           <p:nvPr/>
         </p:nvSpPr>
@@ -4105,7 +4605,7 @@
       </p:sp>
       <p:sp>
         <p:nvSpPr>
-          <p:cNvPr id="5" name="Text 3"/>
+          <p:cNvPr id="8" name="Text 6"/>
           <p:cNvSpPr/>
           <p:nvPr/>
         </p:nvSpPr>
@@ -4144,7 +4644,7 @@
       </p:sp>
       <p:sp>
         <p:nvSpPr>
-          <p:cNvPr id="6" name="Text 4"/>
+          <p:cNvPr id="9" name="Text 7"/>
           <p:cNvSpPr/>
           <p:nvPr/>
         </p:nvSpPr>
@@ -4317,14 +4817,74 @@
       </p:sp>
       <p:sp>
         <p:nvSpPr>
-          <p:cNvPr id="5" name="Text 3"/>
-          <p:cNvSpPr/>
-          <p:nvPr/>
-        </p:nvSpPr>
-        <p:spPr>
-          <a:xfrm>
-            <a:off x="1097280" y="2971800"/>
-            <a:ext cx="2788920" cy="457200"/>
+          <p:cNvPr id="5" name="Shape 3"/>
+          <p:cNvSpPr/>
+          <p:nvPr/>
+        </p:nvSpPr>
+        <p:spPr>
+          <a:xfrm>
+            <a:off x="1097280" y="2944368"/>
+            <a:ext cx="502920" cy="502920"/>
+          </a:xfrm>
+          <a:prstGeom prst="ellipse">
+            <a:avLst/>
+          </a:prstGeom>
+          <a:solidFill>
+            <a:srgbClr val="F4A300"/>
+          </a:solidFill>
+          <a:ln/>
+        </p:spPr>
+      </p:sp>
+      <p:sp>
+        <p:nvSpPr>
+          <p:cNvPr id="6" name="Shape 4"/>
+          <p:cNvSpPr/>
+          <p:nvPr/>
+        </p:nvSpPr>
+        <p:spPr>
+          <a:xfrm>
+            <a:off x="1270284" y="3055010"/>
+            <a:ext cx="156911" cy="156911"/>
+          </a:xfrm>
+          <a:prstGeom prst="ellipse">
+            <a:avLst/>
+          </a:prstGeom>
+          <a:solidFill>
+            <a:srgbClr val="FFFFFF"/>
+          </a:solidFill>
+          <a:ln/>
+        </p:spPr>
+      </p:sp>
+      <p:sp>
+        <p:nvSpPr>
+          <p:cNvPr id="7" name="Shape 5"/>
+          <p:cNvSpPr/>
+          <p:nvPr/>
+        </p:nvSpPr>
+        <p:spPr>
+          <a:xfrm flipV="1">
+            <a:off x="1285976" y="3187982"/>
+            <a:ext cx="125529" cy="130759"/>
+          </a:xfrm>
+          <a:prstGeom prst="triangle">
+            <a:avLst/>
+          </a:prstGeom>
+          <a:solidFill>
+            <a:srgbClr val="FFFFFF"/>
+          </a:solidFill>
+          <a:ln/>
+        </p:spPr>
+      </p:sp>
+      <p:sp>
+        <p:nvSpPr>
+          <p:cNvPr id="8" name="Text 6"/>
+          <p:cNvSpPr/>
+          <p:nvPr/>
+        </p:nvSpPr>
+        <p:spPr>
+          <a:xfrm>
+            <a:off x="1783080" y="2907792"/>
+            <a:ext cx="2103120" cy="502920"/>
           </a:xfrm>
           <a:prstGeom prst="rect">
             <a:avLst/>
@@ -4340,7 +4900,7 @@
               <a:buNone/>
             </a:pPr>
             <a:r>
-              <a:rPr lang="en-US" sz="1800" b="1" dirty="0">
+              <a:rPr lang="en-US" sz="1700" b="1" dirty="0">
                 <a:solidFill>
                   <a:srgbClr val="FFCF5C"/>
                 </a:solidFill>
@@ -4350,19 +4910,19 @@
               </a:rPr>
               <a:t>Listing sites</a:t>
             </a:r>
-            <a:endParaRPr lang="en-US" sz="1800" dirty="0"/>
-          </a:p>
-        </p:txBody>
-      </p:sp>
-      <p:sp>
-        <p:nvSpPr>
-          <p:cNvPr id="6" name="Text 4"/>
-          <p:cNvSpPr/>
-          <p:nvPr/>
-        </p:nvSpPr>
-        <p:spPr>
-          <a:xfrm>
-            <a:off x="1097280" y="3474720"/>
+            <a:endParaRPr lang="en-US" sz="1700" dirty="0"/>
+          </a:p>
+        </p:txBody>
+      </p:sp>
+      <p:sp>
+        <p:nvSpPr>
+          <p:cNvPr id="9" name="Text 7"/>
+          <p:cNvSpPr/>
+          <p:nvPr/>
+        </p:nvSpPr>
+        <p:spPr>
+          <a:xfrm>
+            <a:off x="1097280" y="3520440"/>
             <a:ext cx="2788920" cy="1737360"/>
           </a:xfrm>
           <a:prstGeom prst="rect">
@@ -4395,7 +4955,7 @@
       </p:sp>
       <p:sp>
         <p:nvSpPr>
-          <p:cNvPr id="7" name="Shape 5"/>
+          <p:cNvPr id="10" name="Shape 8"/>
           <p:cNvSpPr/>
           <p:nvPr/>
         </p:nvSpPr>
@@ -4419,14 +4979,76 @@
       </p:sp>
       <p:sp>
         <p:nvSpPr>
-          <p:cNvPr id="8" name="Text 6"/>
-          <p:cNvSpPr/>
-          <p:nvPr/>
-        </p:nvSpPr>
-        <p:spPr>
-          <a:xfrm>
-            <a:off x="4709160" y="2971800"/>
-            <a:ext cx="2788920" cy="457200"/>
+          <p:cNvPr id="11" name="Shape 9"/>
+          <p:cNvSpPr/>
+          <p:nvPr/>
+        </p:nvSpPr>
+        <p:spPr>
+          <a:xfrm>
+            <a:off x="4709160" y="2944368"/>
+            <a:ext cx="502920" cy="502920"/>
+          </a:xfrm>
+          <a:prstGeom prst="ellipse">
+            <a:avLst/>
+          </a:prstGeom>
+          <a:solidFill>
+            <a:srgbClr val="F4A300"/>
+          </a:solidFill>
+          <a:ln/>
+        </p:spPr>
+      </p:sp>
+      <p:sp>
+        <p:nvSpPr>
+          <p:cNvPr id="12" name="Shape 10"/>
+          <p:cNvSpPr/>
+          <p:nvPr/>
+        </p:nvSpPr>
+        <p:spPr>
+          <a:xfrm>
+            <a:off x="4816785" y="3085990"/>
+            <a:ext cx="287670" cy="188293"/>
+          </a:xfrm>
+          <a:prstGeom prst="roundRect">
+            <a:avLst>
+              <a:gd name="adj" fmla="val 24281"/>
+            </a:avLst>
+          </a:prstGeom>
+          <a:solidFill>
+            <a:srgbClr val="FFFFFF"/>
+          </a:solidFill>
+          <a:ln/>
+        </p:spPr>
+      </p:sp>
+      <p:sp>
+        <p:nvSpPr>
+          <p:cNvPr id="13" name="Shape 11"/>
+          <p:cNvSpPr/>
+          <p:nvPr/>
+        </p:nvSpPr>
+        <p:spPr>
+          <a:xfrm>
+            <a:off x="4882164" y="3237671"/>
+            <a:ext cx="73225" cy="67995"/>
+          </a:xfrm>
+          <a:prstGeom prst="triangle">
+            <a:avLst/>
+          </a:prstGeom>
+          <a:solidFill>
+            <a:srgbClr val="FFFFFF"/>
+          </a:solidFill>
+          <a:ln/>
+        </p:spPr>
+      </p:sp>
+      <p:sp>
+        <p:nvSpPr>
+          <p:cNvPr id="14" name="Text 12"/>
+          <p:cNvSpPr/>
+          <p:nvPr/>
+        </p:nvSpPr>
+        <p:spPr>
+          <a:xfrm>
+            <a:off x="5394960" y="2907792"/>
+            <a:ext cx="2103120" cy="502920"/>
           </a:xfrm>
           <a:prstGeom prst="rect">
             <a:avLst/>
@@ -4442,7 +5064,7 @@
               <a:buNone/>
             </a:pPr>
             <a:r>
-              <a:rPr lang="en-US" sz="1800" b="1" dirty="0">
+              <a:rPr lang="en-US" sz="1700" b="1" dirty="0">
                 <a:solidFill>
                   <a:srgbClr val="FFCF5C"/>
                 </a:solidFill>
@@ -4452,19 +5074,19 @@
               </a:rPr>
               <a:t>AI chatbots</a:t>
             </a:r>
-            <a:endParaRPr lang="en-US" sz="1800" dirty="0"/>
-          </a:p>
-        </p:txBody>
-      </p:sp>
-      <p:sp>
-        <p:nvSpPr>
-          <p:cNvPr id="9" name="Text 7"/>
-          <p:cNvSpPr/>
-          <p:nvPr/>
-        </p:nvSpPr>
-        <p:spPr>
-          <a:xfrm>
-            <a:off x="4709160" y="3474720"/>
+            <a:endParaRPr lang="en-US" sz="1700" dirty="0"/>
+          </a:p>
+        </p:txBody>
+      </p:sp>
+      <p:sp>
+        <p:nvSpPr>
+          <p:cNvPr id="15" name="Text 13"/>
+          <p:cNvSpPr/>
+          <p:nvPr/>
+        </p:nvSpPr>
+        <p:spPr>
+          <a:xfrm>
+            <a:off x="4709160" y="3520440"/>
             <a:ext cx="2788920" cy="1737360"/>
           </a:xfrm>
           <a:prstGeom prst="rect">
@@ -4497,7 +5119,7 @@
       </p:sp>
       <p:sp>
         <p:nvSpPr>
-          <p:cNvPr id="10" name="Shape 8"/>
+          <p:cNvPr id="16" name="Shape 14"/>
           <p:cNvSpPr/>
           <p:nvPr/>
         </p:nvSpPr>
@@ -4521,14 +5143,54 @@
       </p:sp>
       <p:sp>
         <p:nvSpPr>
-          <p:cNvPr id="11" name="Text 9"/>
-          <p:cNvSpPr/>
-          <p:nvPr/>
-        </p:nvSpPr>
-        <p:spPr>
-          <a:xfrm>
-            <a:off x="8321040" y="2971800"/>
-            <a:ext cx="2788920" cy="457200"/>
+          <p:cNvPr id="17" name="Shape 15"/>
+          <p:cNvSpPr/>
+          <p:nvPr/>
+        </p:nvSpPr>
+        <p:spPr>
+          <a:xfrm>
+            <a:off x="8321040" y="2944368"/>
+            <a:ext cx="502920" cy="502920"/>
+          </a:xfrm>
+          <a:prstGeom prst="ellipse">
+            <a:avLst/>
+          </a:prstGeom>
+          <a:solidFill>
+            <a:srgbClr val="F4A300"/>
+          </a:solidFill>
+          <a:ln/>
+        </p:spPr>
+      </p:sp>
+      <p:sp>
+        <p:nvSpPr>
+          <p:cNvPr id="18" name="Shape 16"/>
+          <p:cNvSpPr/>
+          <p:nvPr/>
+        </p:nvSpPr>
+        <p:spPr>
+          <a:xfrm>
+            <a:off x="8441741" y="3065069"/>
+            <a:ext cx="261518" cy="261518"/>
+          </a:xfrm>
+          <a:prstGeom prst="donut">
+            <a:avLst/>
+          </a:prstGeom>
+          <a:solidFill>
+            <a:srgbClr val="FFFFFF"/>
+          </a:solidFill>
+          <a:ln/>
+        </p:spPr>
+      </p:sp>
+      <p:sp>
+        <p:nvSpPr>
+          <p:cNvPr id="19" name="Text 17"/>
+          <p:cNvSpPr/>
+          <p:nvPr/>
+        </p:nvSpPr>
+        <p:spPr>
+          <a:xfrm>
+            <a:off x="9006840" y="2907792"/>
+            <a:ext cx="2103120" cy="502920"/>
           </a:xfrm>
           <a:prstGeom prst="rect">
             <a:avLst/>
@@ -4544,7 +5206,7 @@
               <a:buNone/>
             </a:pPr>
             <a:r>
-              <a:rPr lang="en-US" sz="1800" b="1" dirty="0">
+              <a:rPr lang="en-US" sz="1700" b="1" dirty="0">
                 <a:solidFill>
                   <a:srgbClr val="FFCF5C"/>
                 </a:solidFill>
@@ -4554,19 +5216,19 @@
               </a:rPr>
               <a:t>Either way</a:t>
             </a:r>
-            <a:endParaRPr lang="en-US" sz="1800" dirty="0"/>
-          </a:p>
-        </p:txBody>
-      </p:sp>
-      <p:sp>
-        <p:nvSpPr>
-          <p:cNvPr id="12" name="Text 10"/>
-          <p:cNvSpPr/>
-          <p:nvPr/>
-        </p:nvSpPr>
-        <p:spPr>
-          <a:xfrm>
-            <a:off x="8321040" y="3474720"/>
+            <a:endParaRPr lang="en-US" sz="1700" dirty="0"/>
+          </a:p>
+        </p:txBody>
+      </p:sp>
+      <p:sp>
+        <p:nvSpPr>
+          <p:cNvPr id="20" name="Text 18"/>
+          <p:cNvSpPr/>
+          <p:nvPr/>
+        </p:nvSpPr>
+        <p:spPr>
+          <a:xfrm>
+            <a:off x="8321040" y="3520440"/>
             <a:ext cx="2788920" cy="1737360"/>
           </a:xfrm>
           <a:prstGeom prst="rect">
@@ -4599,7 +5261,7 @@
       </p:sp>
       <p:sp>
         <p:nvSpPr>
-          <p:cNvPr id="13" name="Text 11"/>
+          <p:cNvPr id="21" name="Text 19"/>
           <p:cNvSpPr/>
           <p:nvPr/>
         </p:nvSpPr>
@@ -4775,14 +5437,76 @@
       </p:sp>
       <p:sp>
         <p:nvSpPr>
-          <p:cNvPr id="5" name="Text 3"/>
-          <p:cNvSpPr/>
-          <p:nvPr/>
-        </p:nvSpPr>
-        <p:spPr>
-          <a:xfrm>
-            <a:off x="1143000" y="2148840"/>
-            <a:ext cx="4572000" cy="457200"/>
+          <p:cNvPr id="5" name="Shape 3"/>
+          <p:cNvSpPr/>
+          <p:nvPr/>
+        </p:nvSpPr>
+        <p:spPr>
+          <a:xfrm>
+            <a:off x="1097280" y="2103120"/>
+            <a:ext cx="502920" cy="502920"/>
+          </a:xfrm>
+          <a:prstGeom prst="ellipse">
+            <a:avLst/>
+          </a:prstGeom>
+          <a:solidFill>
+            <a:srgbClr val="0C8599"/>
+          </a:solidFill>
+          <a:ln/>
+        </p:spPr>
+      </p:sp>
+      <p:sp>
+        <p:nvSpPr>
+          <p:cNvPr id="6" name="Shape 4"/>
+          <p:cNvSpPr/>
+          <p:nvPr/>
+        </p:nvSpPr>
+        <p:spPr>
+          <a:xfrm>
+            <a:off x="1204905" y="2244742"/>
+            <a:ext cx="287670" cy="188293"/>
+          </a:xfrm>
+          <a:prstGeom prst="roundRect">
+            <a:avLst>
+              <a:gd name="adj" fmla="val 24281"/>
+            </a:avLst>
+          </a:prstGeom>
+          <a:solidFill>
+            <a:srgbClr val="FFFFFF"/>
+          </a:solidFill>
+          <a:ln/>
+        </p:spPr>
+      </p:sp>
+      <p:sp>
+        <p:nvSpPr>
+          <p:cNvPr id="7" name="Shape 5"/>
+          <p:cNvSpPr/>
+          <p:nvPr/>
+        </p:nvSpPr>
+        <p:spPr>
+          <a:xfrm>
+            <a:off x="1270284" y="2396423"/>
+            <a:ext cx="73225" cy="67995"/>
+          </a:xfrm>
+          <a:prstGeom prst="triangle">
+            <a:avLst/>
+          </a:prstGeom>
+          <a:solidFill>
+            <a:srgbClr val="FFFFFF"/>
+          </a:solidFill>
+          <a:ln/>
+        </p:spPr>
+      </p:sp>
+      <p:sp>
+        <p:nvSpPr>
+          <p:cNvPr id="8" name="Text 6"/>
+          <p:cNvSpPr/>
+          <p:nvPr/>
+        </p:nvSpPr>
+        <p:spPr>
+          <a:xfrm>
+            <a:off x="1783080" y="2103120"/>
+            <a:ext cx="3840480" cy="502920"/>
           </a:xfrm>
           <a:prstGeom prst="rect">
             <a:avLst/>
@@ -4814,13 +5538,13 @@
       </p:sp>
       <p:sp>
         <p:nvSpPr>
-          <p:cNvPr id="6" name="Text 4"/>
-          <p:cNvSpPr/>
-          <p:nvPr/>
-        </p:nvSpPr>
-        <p:spPr>
-          <a:xfrm>
-            <a:off x="1143000" y="2743200"/>
+          <p:cNvPr id="9" name="Text 7"/>
+          <p:cNvSpPr/>
+          <p:nvPr/>
+        </p:nvSpPr>
+        <p:spPr>
+          <a:xfrm>
+            <a:off x="1143000" y="2788920"/>
             <a:ext cx="4480560" cy="3108960"/>
           </a:xfrm>
           <a:prstGeom prst="rect">
@@ -4920,7 +5644,7 @@
       </p:sp>
       <p:sp>
         <p:nvSpPr>
-          <p:cNvPr id="7" name="Shape 5"/>
+          <p:cNvPr id="10" name="Shape 8"/>
           <p:cNvSpPr/>
           <p:nvPr/>
         </p:nvSpPr>
@@ -4947,14 +5671,74 @@
       </p:sp>
       <p:sp>
         <p:nvSpPr>
-          <p:cNvPr id="8" name="Text 6"/>
-          <p:cNvSpPr/>
-          <p:nvPr/>
-        </p:nvSpPr>
-        <p:spPr>
-          <a:xfrm>
-            <a:off x="6583680" y="2148840"/>
-            <a:ext cx="4572000" cy="457200"/>
+          <p:cNvPr id="11" name="Shape 9"/>
+          <p:cNvSpPr/>
+          <p:nvPr/>
+        </p:nvSpPr>
+        <p:spPr>
+          <a:xfrm>
+            <a:off x="6537960" y="2103120"/>
+            <a:ext cx="502920" cy="502920"/>
+          </a:xfrm>
+          <a:prstGeom prst="ellipse">
+            <a:avLst/>
+          </a:prstGeom>
+          <a:solidFill>
+            <a:srgbClr val="2D6A4F"/>
+          </a:solidFill>
+          <a:ln/>
+        </p:spPr>
+      </p:sp>
+      <p:sp>
+        <p:nvSpPr>
+          <p:cNvPr id="12" name="Shape 10"/>
+          <p:cNvSpPr/>
+          <p:nvPr/>
+        </p:nvSpPr>
+        <p:spPr>
+          <a:xfrm>
+            <a:off x="6710964" y="2213762"/>
+            <a:ext cx="156911" cy="156911"/>
+          </a:xfrm>
+          <a:prstGeom prst="ellipse">
+            <a:avLst/>
+          </a:prstGeom>
+          <a:solidFill>
+            <a:srgbClr val="FFFFFF"/>
+          </a:solidFill>
+          <a:ln/>
+        </p:spPr>
+      </p:sp>
+      <p:sp>
+        <p:nvSpPr>
+          <p:cNvPr id="13" name="Shape 11"/>
+          <p:cNvSpPr/>
+          <p:nvPr/>
+        </p:nvSpPr>
+        <p:spPr>
+          <a:xfrm flipV="1">
+            <a:off x="6726656" y="2346734"/>
+            <a:ext cx="125529" cy="130759"/>
+          </a:xfrm>
+          <a:prstGeom prst="triangle">
+            <a:avLst/>
+          </a:prstGeom>
+          <a:solidFill>
+            <a:srgbClr val="FFFFFF"/>
+          </a:solidFill>
+          <a:ln/>
+        </p:spPr>
+      </p:sp>
+      <p:sp>
+        <p:nvSpPr>
+          <p:cNvPr id="14" name="Text 12"/>
+          <p:cNvSpPr/>
+          <p:nvPr/>
+        </p:nvSpPr>
+        <p:spPr>
+          <a:xfrm>
+            <a:off x="7223760" y="2103120"/>
+            <a:ext cx="3840480" cy="502920"/>
           </a:xfrm>
           <a:prstGeom prst="rect">
             <a:avLst/>
@@ -4986,13 +5770,13 @@
       </p:sp>
       <p:sp>
         <p:nvSpPr>
-          <p:cNvPr id="9" name="Text 7"/>
-          <p:cNvSpPr/>
-          <p:nvPr/>
-        </p:nvSpPr>
-        <p:spPr>
-          <a:xfrm>
-            <a:off x="6583680" y="2743200"/>
+          <p:cNvPr id="15" name="Text 13"/>
+          <p:cNvSpPr/>
+          <p:nvPr/>
+        </p:nvSpPr>
+        <p:spPr>
+          <a:xfrm>
+            <a:off x="6583680" y="2788920"/>
             <a:ext cx="4480560" cy="3108960"/>
           </a:xfrm>
           <a:prstGeom prst="rect">
@@ -5092,7 +5876,7 @@
       </p:sp>
       <p:sp>
         <p:nvSpPr>
-          <p:cNvPr id="10" name="Text 8"/>
+          <p:cNvPr id="16" name="Text 14"/>
           <p:cNvSpPr/>
           <p:nvPr/>
         </p:nvSpPr>
@@ -5200,9 +5984,41 @@
           </a:p>
         </p:txBody>
       </p:sp>
+      <p:sp>
+        <p:nvSpPr>
+          <p:cNvPr id="3" name="Shape 1"/>
+          <p:cNvSpPr/>
+          <p:nvPr/>
+        </p:nvSpPr>
+        <p:spPr>
+          <a:xfrm rot="72000">
+            <a:off x="5129784" y="1106424"/>
+            <a:ext cx="6565392" cy="4199382"/>
+          </a:xfrm>
+          <a:prstGeom prst="rect">
+            <a:avLst/>
+          </a:prstGeom>
+          <a:solidFill>
+            <a:srgbClr val="FFFFFF"/>
+          </a:solidFill>
+          <a:ln w="19050">
+            <a:solidFill>
+              <a:srgbClr val="0C8599"/>
+            </a:solidFill>
+            <a:prstDash val="solid"/>
+          </a:ln>
+          <a:effectLst>
+            <a:outerShdw sx="100000" sy="100000" kx="0" ky="0" algn="bl" rotWithShape="0" blurRad="88900" dist="38100" dir="5400000">
+              <a:srgbClr val="1F2D27">
+                <a:alpha val="45000"/>
+              </a:srgbClr>
+            </a:outerShdw>
+          </a:effectLst>
+        </p:spPr>
+      </p:sp>
       <p:pic>
         <p:nvPicPr>
-          <p:cNvPr id="3" name="Image 0" descr="/Users/gong/Desktop/Sasin/Gen AI Class/travel-3d-simulator/report/figures/cnr_05_editor_slide.png">    </p:cNvPr>
+          <p:cNvPr id="4" name="Image 0" descr="/Users/gong/Desktop/Sasin/Gen AI Class/travel-3d-simulator/report/figures/cnr_05_editor_slide.png">    </p:cNvPr>
           <p:cNvPicPr>
             <a:picLocks noChangeAspect="1"/>
           </p:cNvPicPr>
@@ -5215,39 +6031,15 @@
           </a:stretch>
         </p:blipFill>
         <p:spPr>
-          <a:xfrm>
-            <a:off x="5029200" y="1005840"/>
-            <a:ext cx="6766560" cy="4229100"/>
+          <a:xfrm rot="72000">
+            <a:off x="5257800" y="1234440"/>
+            <a:ext cx="6309360" cy="3943350"/>
           </a:xfrm>
           <a:prstGeom prst="rect">
             <a:avLst/>
           </a:prstGeom>
         </p:spPr>
       </p:pic>
-      <p:sp>
-        <p:nvSpPr>
-          <p:cNvPr id="4" name="Shape 1"/>
-          <p:cNvSpPr/>
-          <p:nvPr/>
-        </p:nvSpPr>
-        <p:spPr>
-          <a:xfrm>
-            <a:off x="5029200" y="1005840"/>
-            <a:ext cx="6766560" cy="4229100"/>
-          </a:xfrm>
-          <a:prstGeom prst="roundRect">
-            <a:avLst>
-              <a:gd name="adj" fmla="val 865"/>
-            </a:avLst>
-          </a:prstGeom>
-          <a:ln w="19050">
-            <a:solidFill>
-              <a:srgbClr val="0C8599"/>
-            </a:solidFill>
-            <a:prstDash val="solid"/>
-          </a:ln>
-        </p:spPr>
-      </p:sp>
       <p:sp>
         <p:nvSpPr>
           <p:cNvPr id="5" name="Text 2"/>
@@ -5324,7 +6116,7 @@
                 <a:ea typeface="Calibri" pitchFamily="34" charset="-122"/>
                 <a:cs typeface="Calibri" pitchFamily="34" charset="-120"/>
               </a:rPr>
-              <a:t>Cours Saleya Market scores 0.94 — strong match, perfect cost &amp; time fit</a:t>
+              <a:t>Promenade des Anglais scores 0.93 — strong match, perfect cost &amp; time fit</a:t>
             </a:r>
             <a:endParaRPr lang="en-US" sz="1400" dirty="0"/>
           </a:p>
@@ -5482,9 +6274,41 @@
           </a:p>
         </p:txBody>
       </p:sp>
+      <p:sp>
+        <p:nvSpPr>
+          <p:cNvPr id="3" name="Shape 1"/>
+          <p:cNvSpPr/>
+          <p:nvPr/>
+        </p:nvSpPr>
+        <p:spPr>
+          <a:xfrm rot="-84000">
+            <a:off x="5449824" y="1152144"/>
+            <a:ext cx="6291072" cy="4499420"/>
+          </a:xfrm>
+          <a:prstGeom prst="rect">
+            <a:avLst/>
+          </a:prstGeom>
+          <a:solidFill>
+            <a:srgbClr val="FFFFFF"/>
+          </a:solidFill>
+          <a:ln w="19050">
+            <a:solidFill>
+              <a:srgbClr val="F4A300"/>
+            </a:solidFill>
+            <a:prstDash val="solid"/>
+          </a:ln>
+          <a:effectLst>
+            <a:outerShdw sx="100000" sy="100000" kx="0" ky="0" algn="bl" rotWithShape="0" blurRad="88900" dist="38100" dir="5400000">
+              <a:srgbClr val="1F2D27">
+                <a:alpha val="45000"/>
+              </a:srgbClr>
+            </a:outerShdw>
+          </a:effectLst>
+        </p:spPr>
+      </p:sp>
       <p:pic>
         <p:nvPicPr>
-          <p:cNvPr id="3" name="Image 0" descr="/Users/gong/Desktop/Sasin/Gen AI Class/travel-3d-simulator/report/figures/cnr_04_walk.png">    </p:cNvPr>
+          <p:cNvPr id="4" name="Image 0" descr="/Users/gong/Desktop/Sasin/Gen AI Class/travel-3d-simulator/report/figures/cnr_04_walk.png">    </p:cNvPr>
           <p:cNvPicPr>
             <a:picLocks noChangeAspect="1"/>
           </p:cNvPicPr>
@@ -5497,39 +6321,15 @@
           </a:stretch>
         </p:blipFill>
         <p:spPr>
-          <a:xfrm>
-            <a:off x="5349240" y="1005840"/>
-            <a:ext cx="6492240" cy="4564856"/>
+          <a:xfrm rot="-84000">
+            <a:off x="5577840" y="1280160"/>
+            <a:ext cx="6035040" cy="4243388"/>
           </a:xfrm>
           <a:prstGeom prst="rect">
             <a:avLst/>
           </a:prstGeom>
         </p:spPr>
       </p:pic>
-      <p:sp>
-        <p:nvSpPr>
-          <p:cNvPr id="4" name="Shape 1"/>
-          <p:cNvSpPr/>
-          <p:nvPr/>
-        </p:nvSpPr>
-        <p:spPr>
-          <a:xfrm>
-            <a:off x="5349240" y="1005840"/>
-            <a:ext cx="6492240" cy="4564856"/>
-          </a:xfrm>
-          <a:prstGeom prst="roundRect">
-            <a:avLst>
-              <a:gd name="adj" fmla="val 801"/>
-            </a:avLst>
-          </a:prstGeom>
-          <a:ln w="19050">
-            <a:solidFill>
-              <a:srgbClr val="F4A300"/>
-            </a:solidFill>
-            <a:prstDash val="solid"/>
-          </a:ln>
-        </p:spPr>
-      </p:sp>
       <p:sp>
         <p:nvSpPr>
           <p:cNvPr id="5" name="Text 2"/>
@@ -5567,7 +6367,7 @@
                 <a:ea typeface="Calibri" pitchFamily="34" charset="-122"/>
                 <a:cs typeface="Calibri" pitchFamily="34" charset="-120"/>
               </a:rPr>
-              <a:t>LLM reads Cours Saleya Market's reviews</a:t>
+              <a:t>LLM reads Promenade des Anglais' reviews</a:t>
             </a:r>
             <a:endParaRPr lang="en-US" sz="1450" dirty="0"/>
           </a:p>
@@ -5665,7 +6465,7 @@
         </p:nvSpPr>
         <p:spPr>
           <a:xfrm>
-            <a:off x="548640" y="5394960"/>
+            <a:off x="548640" y="5577840"/>
             <a:ext cx="4572000" cy="640080"/>
           </a:xfrm>
           <a:prstGeom prst="rect">
@@ -6018,9 +6818,41 @@
           </a:p>
         </p:txBody>
       </p:sp>
+      <p:sp>
+        <p:nvSpPr>
+          <p:cNvPr id="4" name="Shape 2"/>
+          <p:cNvSpPr/>
+          <p:nvPr/>
+        </p:nvSpPr>
+        <p:spPr>
+          <a:xfrm rot="54000">
+            <a:off x="4443984" y="2157984"/>
+            <a:ext cx="7022592" cy="2259290"/>
+          </a:xfrm>
+          <a:prstGeom prst="rect">
+            <a:avLst/>
+          </a:prstGeom>
+          <a:solidFill>
+            <a:srgbClr val="FFFFFF"/>
+          </a:solidFill>
+          <a:ln w="19050">
+            <a:solidFill>
+              <a:srgbClr val="F4A300"/>
+            </a:solidFill>
+            <a:prstDash val="solid"/>
+          </a:ln>
+          <a:effectLst>
+            <a:outerShdw sx="100000" sy="100000" kx="0" ky="0" algn="bl" rotWithShape="0" blurRad="88900" dist="38100" dir="5400000">
+              <a:srgbClr val="1F2D27">
+                <a:alpha val="45000"/>
+              </a:srgbClr>
+            </a:outerShdw>
+          </a:effectLst>
+        </p:spPr>
+      </p:sp>
       <p:pic>
         <p:nvPicPr>
-          <p:cNvPr id="4" name="Image 0" descr="/Users/gong/Desktop/Sasin/Gen AI Class/travel-3d-simulator/report/figures/concierge_chat.png">    </p:cNvPr>
+          <p:cNvPr id="5" name="Image 0" descr="/Users/gong/Desktop/Sasin/Gen AI Class/travel-3d-simulator/report/figures/concierge_chat.png">    </p:cNvPr>
           <p:cNvPicPr>
             <a:picLocks noChangeAspect="1"/>
           </p:cNvPicPr>
@@ -6033,9 +6865,9 @@
           </a:stretch>
         </p:blipFill>
         <p:spPr>
-          <a:xfrm>
-            <a:off x="4206240" y="2011680"/>
-            <a:ext cx="7315200" cy="2165684"/>
+          <a:xfrm rot="54000">
+            <a:off x="4572000" y="2286000"/>
+            <a:ext cx="6766560" cy="2003258"/>
           </a:xfrm>
           <a:prstGeom prst="rect">
             <a:avLst/>
@@ -6044,30 +6876,6 @@
       </p:pic>
       <p:sp>
         <p:nvSpPr>
-          <p:cNvPr id="5" name="Shape 2"/>
-          <p:cNvSpPr/>
-          <p:nvPr/>
-        </p:nvSpPr>
-        <p:spPr>
-          <a:xfrm>
-            <a:off x="4206240" y="2011680"/>
-            <a:ext cx="7315200" cy="2165684"/>
-          </a:xfrm>
-          <a:prstGeom prst="roundRect">
-            <a:avLst>
-              <a:gd name="adj" fmla="val 1689"/>
-            </a:avLst>
-          </a:prstGeom>
-          <a:ln w="19050">
-            <a:solidFill>
-              <a:srgbClr val="F4A300"/>
-            </a:solidFill>
-            <a:prstDash val="solid"/>
-          </a:ln>
-        </p:spPr>
-      </p:sp>
-      <p:sp>
-        <p:nvSpPr>
           <p:cNvPr id="6" name="Text 3"/>
           <p:cNvSpPr/>
           <p:nvPr/>
@@ -6075,7 +6883,7 @@
         <p:spPr>
           <a:xfrm>
             <a:off x="548640" y="1463040"/>
-            <a:ext cx="3383280" cy="4114800"/>
+            <a:ext cx="3566160" cy="4114800"/>
           </a:xfrm>
           <a:prstGeom prst="rect">
             <a:avLst/>
@@ -6391,14 +7199,54 @@
       </p:sp>
       <p:sp>
         <p:nvSpPr>
-          <p:cNvPr id="5" name="Text 3"/>
-          <p:cNvSpPr/>
-          <p:nvPr/>
-        </p:nvSpPr>
-        <p:spPr>
-          <a:xfrm>
-            <a:off x="1143000" y="2377440"/>
-            <a:ext cx="4572000" cy="457200"/>
+          <p:cNvPr id="5" name="Shape 3"/>
+          <p:cNvSpPr/>
+          <p:nvPr/>
+        </p:nvSpPr>
+        <p:spPr>
+          <a:xfrm>
+            <a:off x="1097280" y="2377440"/>
+            <a:ext cx="457200" cy="457200"/>
+          </a:xfrm>
+          <a:prstGeom prst="ellipse">
+            <a:avLst/>
+          </a:prstGeom>
+          <a:solidFill>
+            <a:srgbClr val="F4A300"/>
+          </a:solidFill>
+          <a:ln/>
+        </p:spPr>
+      </p:sp>
+      <p:sp>
+        <p:nvSpPr>
+          <p:cNvPr id="6" name="Shape 4"/>
+          <p:cNvSpPr/>
+          <p:nvPr/>
+        </p:nvSpPr>
+        <p:spPr>
+          <a:xfrm>
+            <a:off x="1207008" y="2487168"/>
+            <a:ext cx="237744" cy="237744"/>
+          </a:xfrm>
+          <a:prstGeom prst="star5">
+            <a:avLst/>
+          </a:prstGeom>
+          <a:solidFill>
+            <a:srgbClr val="FFFFFF"/>
+          </a:solidFill>
+          <a:ln/>
+        </p:spPr>
+      </p:sp>
+      <p:sp>
+        <p:nvSpPr>
+          <p:cNvPr id="7" name="Text 5"/>
+          <p:cNvSpPr/>
+          <p:nvPr/>
+        </p:nvSpPr>
+        <p:spPr>
+          <a:xfrm>
+            <a:off x="1691640" y="2377440"/>
+            <a:ext cx="3657600" cy="457200"/>
           </a:xfrm>
           <a:prstGeom prst="rect">
             <a:avLst/>
@@ -6430,13 +7278,13 @@
       </p:sp>
       <p:sp>
         <p:nvSpPr>
-          <p:cNvPr id="6" name="Text 4"/>
-          <p:cNvSpPr/>
-          <p:nvPr/>
-        </p:nvSpPr>
-        <p:spPr>
-          <a:xfrm>
-            <a:off x="1143000" y="2971800"/>
+          <p:cNvPr id="8" name="Text 6"/>
+          <p:cNvSpPr/>
+          <p:nvPr/>
+        </p:nvSpPr>
+        <p:spPr>
+          <a:xfrm>
+            <a:off x="1143000" y="3063240"/>
             <a:ext cx="4480560" cy="2560320"/>
           </a:xfrm>
           <a:prstGeom prst="rect">
@@ -6536,7 +7384,7 @@
       </p:sp>
       <p:sp>
         <p:nvSpPr>
-          <p:cNvPr id="7" name="Shape 5"/>
+          <p:cNvPr id="9" name="Shape 7"/>
           <p:cNvSpPr/>
           <p:nvPr/>
         </p:nvSpPr>
@@ -6565,14 +7413,54 @@
       </p:sp>
       <p:sp>
         <p:nvSpPr>
-          <p:cNvPr id="8" name="Text 6"/>
-          <p:cNvSpPr/>
-          <p:nvPr/>
-        </p:nvSpPr>
-        <p:spPr>
-          <a:xfrm>
-            <a:off x="6583680" y="2377440"/>
-            <a:ext cx="4572000" cy="457200"/>
+          <p:cNvPr id="10" name="Shape 8"/>
+          <p:cNvSpPr/>
+          <p:nvPr/>
+        </p:nvSpPr>
+        <p:spPr>
+          <a:xfrm>
+            <a:off x="6537960" y="2377440"/>
+            <a:ext cx="457200" cy="457200"/>
+          </a:xfrm>
+          <a:prstGeom prst="ellipse">
+            <a:avLst/>
+          </a:prstGeom>
+          <a:solidFill>
+            <a:srgbClr val="2D6A4F"/>
+          </a:solidFill>
+          <a:ln/>
+        </p:spPr>
+      </p:sp>
+      <p:sp>
+        <p:nvSpPr>
+          <p:cNvPr id="11" name="Shape 9"/>
+          <p:cNvSpPr/>
+          <p:nvPr/>
+        </p:nvSpPr>
+        <p:spPr>
+          <a:xfrm>
+            <a:off x="6647688" y="2487168"/>
+            <a:ext cx="237744" cy="237744"/>
+          </a:xfrm>
+          <a:prstGeom prst="donut">
+            <a:avLst/>
+          </a:prstGeom>
+          <a:solidFill>
+            <a:srgbClr val="FFFFFF"/>
+          </a:solidFill>
+          <a:ln/>
+        </p:spPr>
+      </p:sp>
+      <p:sp>
+        <p:nvSpPr>
+          <p:cNvPr id="12" name="Text 10"/>
+          <p:cNvSpPr/>
+          <p:nvPr/>
+        </p:nvSpPr>
+        <p:spPr>
+          <a:xfrm>
+            <a:off x="7132320" y="2377440"/>
+            <a:ext cx="3931920" cy="457200"/>
           </a:xfrm>
           <a:prstGeom prst="rect">
             <a:avLst/>
@@ -6604,13 +7492,13 @@
       </p:sp>
       <p:sp>
         <p:nvSpPr>
-          <p:cNvPr id="9" name="Text 7"/>
-          <p:cNvSpPr/>
-          <p:nvPr/>
-        </p:nvSpPr>
-        <p:spPr>
-          <a:xfrm>
-            <a:off x="6583680" y="2971800"/>
+          <p:cNvPr id="13" name="Text 11"/>
+          <p:cNvSpPr/>
+          <p:nvPr/>
+        </p:nvSpPr>
+        <p:spPr>
+          <a:xfrm>
+            <a:off x="6583680" y="3063240"/>
             <a:ext cx="4480560" cy="2560320"/>
           </a:xfrm>
           <a:prstGeom prst="rect">
@@ -6710,7 +7598,7 @@
       </p:sp>
       <p:sp>
         <p:nvSpPr>
-          <p:cNvPr id="10" name="Text 8"/>
+          <p:cNvPr id="14" name="Text 12"/>
           <p:cNvSpPr/>
           <p:nvPr/>
         </p:nvSpPr>

</xml_diff>